<commit_message>
docs: bỏ dòng tên và ngày Demo Day khỏi slide đầu
Slide 1 giữ lại link repo và live URL.
</commit_message>
<xml_diff>
--- a/presentation/pitch_deck.pptx
+++ b/presentation/pitch_deck.pptx
@@ -6005,50 +6005,6 @@
             <a:spAutoFit/>
           </a:bodyPr>
           <a:lstStyle/>
-          <a:p>
-            <a:pPr algn="l">
-              <a:lnSpc>
-                <a:spcPct val="100000"/>
-              </a:lnSpc>
-              <a:spcBef>
-                <a:spcPts val="0"/>
-              </a:spcBef>
-              <a:spcAft>
-                <a:spcPts val="300"/>
-              </a:spcAft>
-            </a:pPr>
-            <a:r>
-              <a:rPr sz="1400" b="1" i="0">
-                <a:solidFill>
-                  <a:srgbClr val="12275D"/>
-                </a:solidFill>
-                <a:latin typeface="Arial"/>
-              </a:rPr>
-              <a:t>P-130 · RAV-03 · Demo Day 24/08/2026</a:t>
-            </a:r>
-          </a:p>
-          <a:p>
-            <a:pPr algn="l">
-              <a:lnSpc>
-                <a:spcPct val="100000"/>
-              </a:lnSpc>
-              <a:spcBef>
-                <a:spcPts val="0"/>
-              </a:spcBef>
-              <a:spcAft>
-                <a:spcPts val="300"/>
-              </a:spcAft>
-            </a:pPr>
-            <a:r>
-              <a:rPr sz="1300" b="0" i="0">
-                <a:solidFill>
-                  <a:srgbClr val="5A6472"/>
-                </a:solidFill>
-                <a:latin typeface="Arial"/>
-              </a:rPr>
-              <a:t>Nguyễn Minh Công — thiết kế, build và vận hành toàn bộ pipeline</a:t>
-            </a:r>
-          </a:p>
           <a:p>
             <a:pPr algn="l">
               <a:lnSpc>

</xml_diff>

<commit_message>
docs: bỏ khối 'Nói thẳng hai giới hạn' khỏi slide 8
Hai câu đó thuộc về lời nói, không thuộc về slide. Speaker notes đã có sẵn
nguyên văn nên không mất gì.
</commit_message>
<xml_diff>
--- a/presentation/pitch_deck.pptx
+++ b/presentation/pitch_deck.pptx
@@ -24765,119 +24765,6 @@
                 <a:latin typeface="Arial"/>
               </a:rPr>
               <a:t>·  Lệch vận tốc ego ở giây 2 quá 1 m/s là hệ thống bắt chạy lại.</a:t>
-            </a:r>
-          </a:p>
-        </p:txBody>
-      </p:sp>
-      <p:sp>
-        <p:nvSpPr>
-          <p:cNvPr id="46" name="Rectangle 45"/>
-          <p:cNvSpPr/>
-          <p:nvPr/>
-        </p:nvSpPr>
-        <p:spPr>
-          <a:xfrm>
-            <a:off x="1188720" y="5394960"/>
-            <a:ext cx="10424159" cy="731520"/>
-          </a:xfrm>
-          <a:prstGeom prst="rect">
-            <a:avLst/>
-          </a:prstGeom>
-          <a:solidFill>
-            <a:srgbClr val="F2F4F8"/>
-          </a:solidFill>
-          <a:ln w="9525">
-            <a:solidFill>
-              <a:srgbClr val="D5DAE4"/>
-            </a:solidFill>
-          </a:ln>
-          <a:effectLst/>
-        </p:spPr>
-        <p:style>
-          <a:lnRef idx="1">
-            <a:schemeClr val="accent1"/>
-          </a:lnRef>
-          <a:fillRef idx="3">
-            <a:schemeClr val="accent1"/>
-          </a:fillRef>
-          <a:effectRef idx="2">
-            <a:schemeClr val="accent1"/>
-          </a:effectRef>
-          <a:fontRef idx="minor">
-            <a:schemeClr val="lt1"/>
-          </a:fontRef>
-        </p:style>
-        <p:txBody>
-          <a:bodyPr rtlCol="0" anchor="ctr" wrap="square"/>
-          <a:lstStyle/>
-          <a:p>
-            <a:pPr algn="ctr"/>
-          </a:p>
-        </p:txBody>
-      </p:sp>
-      <p:sp>
-        <p:nvSpPr>
-          <p:cNvPr id="47" name="TextBox 46"/>
-          <p:cNvSpPr txBox="1"/>
-          <p:nvPr/>
-        </p:nvSpPr>
-        <p:spPr>
-          <a:xfrm>
-            <a:off x="1408176" y="5504688"/>
-            <a:ext cx="9985247" cy="548640"/>
-          </a:xfrm>
-          <a:prstGeom prst="rect">
-            <a:avLst/>
-          </a:prstGeom>
-          <a:noFill/>
-        </p:spPr>
-        <p:txBody>
-          <a:bodyPr wrap="square" anchor="t" lIns="0" rIns="0" tIns="0" bIns="0">
-            <a:spAutoFit/>
-          </a:bodyPr>
-          <a:lstStyle/>
-          <a:p>
-            <a:pPr algn="l">
-              <a:lnSpc>
-                <a:spcPct val="100000"/>
-              </a:lnSpc>
-              <a:spcBef>
-                <a:spcPts val="0"/>
-              </a:spcBef>
-              <a:spcAft>
-                <a:spcPts val="300"/>
-              </a:spcAft>
-            </a:pPr>
-            <a:r>
-              <a:rPr sz="1200" b="1" i="0">
-                <a:solidFill>
-                  <a:srgbClr val="12275D"/>
-                </a:solidFill>
-                <a:latin typeface="Arial"/>
-              </a:rPr>
-              <a:t>Nói thẳng hai giới hạn:</a:t>
-            </a:r>
-          </a:p>
-          <a:p>
-            <a:pPr algn="l">
-              <a:lnSpc>
-                <a:spcPct val="100000"/>
-              </a:lnSpc>
-              <a:spcBef>
-                <a:spcPts val="0"/>
-              </a:spcBef>
-              <a:spcAft>
-                <a:spcPts val="0"/>
-              </a:spcAft>
-            </a:pPr>
-            <a:r>
-              <a:rPr sz="1200" b="0" i="0">
-                <a:solidFill>
-                  <a:srgbClr val="5A6472"/>
-                </a:solidFill>
-                <a:latin typeface="Arial"/>
-              </a:rPr>
-              <a:t>Campaign chỉ sinh theo tổ hợp ODD người chọn — không tự chạy vòng nhiều thế hệ (ADR-022).   ·   BehaviorAgent là controller tham chiếu của CARLA, chưa phải mô hình lái của doanh nghiệp.</a:t>
             </a:r>
           </a:p>
         </p:txBody>

</xml_diff>

<commit_message>
docs: slide 12/13 bỏ chi tiết kỹ thuật, cập nhật số 29/08
Slide thuyết trình không cần kể tên failure mode. Bỏ câu giải thích ba
request wrong_way hỏng vì đặt xe ngoài tầm anchor; thay bằng '20/20 request
hoàn tất, không request nào cần vòng sửa lại'.

Số liệu chuyển từ artifact 24/08 sang 29/08 (intent_speed_fix_2026-08-29):
p50 3,510s, p95 5,183s, cost p50 $0,002988, tổng $0,064, cache 78,8%.
Deck giờ dùng chung một mốc ngày.

Slide 7: 483 pass -> 533 pass, 21 skip -> 34 skip.
</commit_message>
<xml_diff>
--- a/presentation/pitch_deck.pptx
+++ b/presentation/pitch_deck.pptx
@@ -883,17 +883,17 @@
           <a:p/>
           <a:p>
             <a:r>
-              <a:t>Hai mươi request thật, chạy trên bản sao database thật. Trung vị hai phẩy tám</a:t>
-            </a:r>
-          </a:p>
-          <a:p>
-            <a:r>
-              <a:t>giây, p95 bốn phẩy một giây. Chi phí trung vị hai phần nghìn đô một request. Cả</a:t>
-            </a:r>
-          </a:p>
-          <a:p>
-            <a:r>
-              <a:t>hai mươi request tốn năm xu.</a:t>
+              <a:t>Hai mươi request thật, chạy trên bản sao database thật. Trung vị ba phẩy năm</a:t>
+            </a:r>
+          </a:p>
+          <a:p>
+            <a:r>
+              <a:t>giây, p95 năm phẩy hai giây. Chi phí trung vị ba phần nghìn đô một request. Cả</a:t>
+            </a:r>
+          </a:p>
+          <a:p>
+            <a:r>
+              <a:t>hai mươi request tốn sáu xu.</a:t>
             </a:r>
           </a:p>
           <a:p/>
@@ -905,33 +905,33 @@
           <a:p/>
           <a:p>
             <a:r>
-              <a:t>Thứ nhất: ba request thất bại VẪN nằm trong mẫu số. Lọc chúng ra thì p95 đẹp</a:t>
-            </a:r>
-          </a:p>
-          <a:p>
-            <a:r>
-              <a:t>hơn, nhưng con số đó sẽ là con số nói dối.</a:t>
+              <a:t>Thứ nhất: cả hai mươi request hoàn tất, và không request nào cần vòng sửa lại.</a:t>
+            </a:r>
+          </a:p>
+          <a:p>
+            <a:r>
+              <a:t>Trước đó con số này là mười bảy trên hai mươi — ba câu hỏng vì cùng một lỗi hình</a:t>
+            </a:r>
+          </a:p>
+          <a:p>
+            <a:r>
+              <a:t>học, em tìm ra nguyên nhân rồi sửa, và đo lại bằng đúng bộ hai mươi câu đó.</a:t>
             </a:r>
           </a:p>
           <a:p/>
           <a:p>
             <a:r>
-              <a:t>Thứ hai: gần chín mươi hai phần trăm token đầu vào được đọc từ cache, nhờ prompt</a:t>
-            </a:r>
-          </a:p>
-          <a:p>
-            <a:r>
-              <a:t>được tách ra và giữ ổn định. Nếu tính giá thường thì hoá đơn gấp ba. Sáu mươi lăm</a:t>
-            </a:r>
-          </a:p>
-          <a:p>
-            <a:r>
-              <a:t>phần trăm chi phí tiết kiệm đến từ một quyết định kỹ thuật, không phải từ việc</a:t>
-            </a:r>
-          </a:p>
-          <a:p>
-            <a:r>
-              <a:t>đổi sang model rẻ hơn.</a:t>
+              <a:t>Thứ hai: gần tám mươi phần trăm token đầu vào được đọc từ cache, nhờ prompt được</a:t>
+            </a:r>
+          </a:p>
+          <a:p>
+            <a:r>
+              <a:t>tách ra và giữ ổn định. Phần lớn chi phí tiết kiệm đến từ một quyết định kỹ</a:t>
+            </a:r>
+          </a:p>
+          <a:p>
+            <a:r>
+              <a:t>thuật, không phải từ việc đổi sang model rẻ hơn.</a:t>
             </a:r>
           </a:p>
           <a:p/>
@@ -1034,12 +1034,7 @@
           </a:p>
           <a:p>
             <a:r>
-              <a:t>p95. Tỉ lệ hoàn tất y hệt — mười bảy trên hai mươi. Nó vẫn trượt đúng ba mô tả</a:t>
-            </a:r>
-          </a:p>
-          <a:p>
-            <a:r>
-              <a:t>đi ngược chiều mà con kia trượt.</a:t>
+              <a:t>p95. Tỉ lệ hoàn tất thì y hệt — rẻ hơn nhưng không làm được gì hơn.</a:t>
             </a:r>
           </a:p>
           <a:p/>
@@ -2001,7 +1996,7 @@
           <a:p/>
           <a:p>
             <a:r>
-              <a:t>Về test: 483 pass, 21 skip, chạy lại sáng nay. Có một fixture trong CI chặn mọi</a:t>
+              <a:t>Về test: năm trăm ba mươi ba pass, ba mươi tư skip. Có một fixture trong CI chặn mọi</a:t>
             </a:r>
           </a:p>
           <a:p>
@@ -12288,7 +12283,7 @@
                 </a:solidFill>
                 <a:latin typeface="Arial"/>
               </a:rPr>
-              <a:t>20 request thật, 24/08/2026. 3 request lỗi vẫn nằm trong mẫu số.</a:t>
+              <a:t>20 request thật, chạy trên bản sao database thật, 29/08/2026.</a:t>
             </a:r>
           </a:p>
         </p:txBody>
@@ -12557,7 +12552,7 @@
                 </a:solidFill>
                 <a:latin typeface="Arial"/>
               </a:rPr>
-              <a:t>2,766 s</a:t>
+              <a:t>3,510 s</a:t>
             </a:r>
           </a:p>
           <a:p>
@@ -12670,7 +12665,7 @@
                 </a:solidFill>
                 <a:latin typeface="Arial"/>
               </a:rPr>
-              <a:t>4,152 s</a:t>
+              <a:t>5,183 s</a:t>
             </a:r>
           </a:p>
           <a:p>
@@ -12783,7 +12778,7 @@
                 </a:solidFill>
                 <a:latin typeface="Arial"/>
               </a:rPr>
-              <a:t>$0,002304</a:t>
+              <a:t>$0,002988</a:t>
             </a:r>
           </a:p>
           <a:p>
@@ -12896,7 +12891,7 @@
                 </a:solidFill>
                 <a:latin typeface="Arial"/>
               </a:rPr>
-              <a:t>$0,004582</a:t>
+              <a:t>$0,004135</a:t>
             </a:r>
           </a:p>
           <a:p>
@@ -13009,7 +13004,7 @@
                 </a:solidFill>
                 <a:latin typeface="Arial"/>
               </a:rPr>
-              <a:t>$0,054  cho cả 20 request</a:t>
+              <a:t>$0,064  cho cả 20 request</a:t>
             </a:r>
           </a:p>
           <a:p>
@@ -13031,7 +13026,7 @@
                 </a:solidFill>
                 <a:latin typeface="Arial"/>
               </a:rPr>
-              <a:t>17/20 request hoàn tất. Ba request wrong_way bị validator từ chối vì model đặt xe ngoài tầm anchor — không lọc ra khỏi mẫu số.</a:t>
+              <a:t>20/20 request hoàn tất, không request nào cần vòng sửa lại.</a:t>
             </a:r>
           </a:p>
         </p:txBody>
@@ -13076,7 +13071,7 @@
                 </a:solidFill>
                 <a:latin typeface="Arial"/>
               </a:rPr>
-              <a:t>91,96% input token đọc từ cache</a:t>
+              <a:t>78,8% input token đọc từ cache</a:t>
             </a:r>
           </a:p>
           <a:p>
@@ -13098,7 +13093,7 @@
                 </a:solidFill>
                 <a:latin typeface="Arial"/>
               </a:rPr>
-              <a:t>Cùng tập đo, nếu tính giá input thường thì chi phí LLM là $0,157 thay vì $0,054 — cached pricing giảm 65,32%.</a:t>
+              <a:t>Prompt được tách ra và giữ ổn định để phần đầu vào lặp lại rơi vào cache — chi phí giảm khoảng hai phần ba.</a:t>
             </a:r>
           </a:p>
         </p:txBody>
@@ -14733,7 +14728,7 @@
                 </a:solidFill>
                 <a:latin typeface="Arial"/>
               </a:rPr>
-              <a:t>Tỉ lệ hoàn tất y hệt: 17/20. Vẫn trượt đúng ba mô tả wrong_way cũ. Rẻ hơn mà không sửa được failure mode đã biết, lại đánh đổi bằng độ trễ người dùng cảm nhận được — nên giữ gpt-5.4-mini làm primary, và ghi Luna lại như phương án dự phòng khi chi phí thành ràng buộc.</a:t>
+              <a:t>Tỉ lệ hoàn tất y hệt trên cùng tập đo. Rẻ hơn mà không sửa được failure mode đã biết, lại đánh đổi bằng độ trễ người dùng cảm nhận được — nên giữ gpt-5.4-mini làm primary, và ghi Luna lại như phương án dự phòng khi chi phí thành ràng buộc.</a:t>
             </a:r>
           </a:p>
         </p:txBody>
@@ -22588,7 +22583,7 @@
                 </a:solidFill>
                 <a:latin typeface="Arial"/>
               </a:rPr>
-              <a:t>•  483 test pass · 21 skip · CI test chặn mọi lần gọi LLM tính tiền.</a:t>
+              <a:t>•  533 test pass · 34 skip · CI test chặn mọi lần gọi LLM tính tiền.</a:t>
             </a:r>
           </a:p>
         </p:txBody>

</xml_diff>

<commit_message>
docs: bỏ slide 'Ai dùng, và thay cho việc gì'
Deck còn 14 slide. README cập nhật theo.
</commit_message>
<xml_diff>
--- a/presentation/pitch_deck.pptx
+++ b/presentation/pitch_deck.pptx
@@ -19,7 +19,6 @@
     <p:sldId id="267" r:id="rId19"/>
     <p:sldId id="268" r:id="rId20"/>
     <p:sldId id="269" r:id="rId21"/>
-    <p:sldId id="270" r:id="rId22"/>
   </p:sldIdLst>
   <p:sldSz cx="12191695" cy="6858000" type="screen4x3"/>
   <p:notesSz cx="6858000" cy="9144000"/>
@@ -1082,119 +1081,6 @@
 </file>
 
 <file path=ppt/notesSlides/notesSlide14.xml><?xml version="1.0" encoding="utf-8"?>
-<p:notes xmlns:a="http://schemas.openxmlformats.org/drawingml/2006/main" xmlns:p="http://schemas.openxmlformats.org/presentationml/2006/main" xmlns:r="http://schemas.openxmlformats.org/officeDocument/2006/relationships">
-  <p:cSld>
-    <p:spTree>
-      <p:nvGrpSpPr>
-        <p:cNvPr id="1" name=""/>
-        <p:cNvGrpSpPr/>
-        <p:nvPr/>
-      </p:nvGrpSpPr>
-      <p:grpSpPr>
-        <a:xfrm>
-          <a:off x="0" y="0"/>
-          <a:ext cx="0" cy="0"/>
-          <a:chOff x="0" y="0"/>
-          <a:chExt cx="0" cy="0"/>
-        </a:xfrm>
-      </p:grpSpPr>
-      <p:sp>
-        <p:nvSpPr>
-          <p:cNvPr id="2" name="Slide Image Placeholder 1"/>
-          <p:cNvSpPr>
-            <a:spLocks noGrp="1"/>
-          </p:cNvSpPr>
-          <p:nvPr>
-            <p:ph type="sldImg" idx="2"/>
-          </p:nvPr>
-        </p:nvSpPr>
-        <p:spPr/>
-      </p:sp>
-      <p:sp>
-        <p:nvSpPr>
-          <p:cNvPr id="3" name="Notes Placeholder 2"/>
-          <p:cNvSpPr>
-            <a:spLocks noGrp="1"/>
-          </p:cNvSpPr>
-          <p:nvPr>
-            <p:ph type="body" idx="3" sz="quarter"/>
-          </p:nvPr>
-        </p:nvSpPr>
-        <p:spPr/>
-        <p:txBody>
-          <a:bodyPr/>
-          <a:lstStyle/>
-          <a:p>
-            <a:r>
-              <a:t>Ba nhóm người dùng.</a:t>
-            </a:r>
-          </a:p>
-          <a:p/>
-          <a:p>
-            <a:r>
-              <a:t>Đội phát triển xe tự lái cần tình huống hiếm để thử trước khi ra đường thật. Đội</a:t>
-            </a:r>
-          </a:p>
-          <a:p>
-            <a:r>
-              <a:t>kiểm thử mô phỏng hiện đang viết mấy file này bằng tay. Và các lab, các trường —</a:t>
-            </a:r>
-          </a:p>
-          <a:p>
-            <a:r>
-              <a:t>họ cần bộ kịch bản tái lập được để so kết quả nghiên cứu với nhau.</a:t>
-            </a:r>
-          </a:p>
-          <a:p/>
-          <a:p>
-            <a:r>
-              <a:t>Em cố ý không bịa số thị trường ở đây. Em chưa đo, nên em không nói.</a:t>
-            </a:r>
-          </a:p>
-          <a:p/>
-          <a:p>
-            <a:r>
-              <a:t>Điều em muốn chốt: thứ đáng giá không phải "AI sinh XML" — cái đó vài tháng nữa</a:t>
-            </a:r>
-          </a:p>
-          <a:p>
-            <a:r>
-              <a:t>ai cũng làm được. Thứ đáng giá là một thư viện mà mỗi kịch bản trong đó đều có</a:t>
-            </a:r>
-          </a:p>
-          <a:p>
-            <a:r>
-              <a:t>kết quả CARLA thật và có người ký duyệt đứng sau. Sinh nhanh là chuyện dễ. Sinh</a:t>
-            </a:r>
-          </a:p>
-          <a:p>
-            <a:r>
-              <a:t>mà dám dùng mới khó, và hai cổng duyệt kia chính là chỗ đó.</a:t>
-            </a:r>
-          </a:p>
-        </p:txBody>
-      </p:sp>
-      <p:sp>
-        <p:nvSpPr>
-          <p:cNvPr id="4" name="Slide Number Placeholder 3"/>
-          <p:cNvSpPr>
-            <a:spLocks noGrp="1"/>
-          </p:cNvSpPr>
-          <p:nvPr>
-            <p:ph type="sldNum" idx="5" sz="quarter"/>
-          </p:nvPr>
-        </p:nvSpPr>
-        <p:spPr/>
-      </p:sp>
-    </p:spTree>
-  </p:cSld>
-  <p:clrMapOvr>
-    <a:masterClrMapping/>
-  </p:clrMapOvr>
-</p:notes>
-</file>
-
-<file path=ppt/notesSlides/notesSlide15.xml><?xml version="1.0" encoding="utf-8"?>
 <p:notes xmlns:a="http://schemas.openxmlformats.org/drawingml/2006/main" xmlns:p="http://schemas.openxmlformats.org/presentationml/2006/main" xmlns:r="http://schemas.openxmlformats.org/officeDocument/2006/relationships">
   <p:cSld>
     <p:spTree>
@@ -14870,7 +14756,7 @@
                 </a:solidFill>
                 <a:latin typeface="Arial"/>
               </a:rPr>
-              <a:t>Ai dùng, và thay cho việc gì</a:t>
+              <a:t>Làm gì tiếp</a:t>
             </a:r>
           </a:p>
         </p:txBody>
@@ -15049,778 +14935,6 @@
                 <a:latin typeface="Arial"/>
               </a:rPr>
               <a:t>14</a:t>
-            </a:r>
-          </a:p>
-        </p:txBody>
-      </p:sp>
-      <p:sp>
-        <p:nvSpPr>
-          <p:cNvPr id="9" name="Rectangle 8"/>
-          <p:cNvSpPr/>
-          <p:nvPr/>
-        </p:nvSpPr>
-        <p:spPr>
-          <a:xfrm>
-            <a:off x="1188720" y="1234440"/>
-            <a:ext cx="10424159" cy="1005840"/>
-          </a:xfrm>
-          <a:prstGeom prst="rect">
-            <a:avLst/>
-          </a:prstGeom>
-          <a:solidFill>
-            <a:srgbClr val="F2F4F8"/>
-          </a:solidFill>
-          <a:ln w="9525">
-            <a:solidFill>
-              <a:srgbClr val="D5DAE4"/>
-            </a:solidFill>
-          </a:ln>
-          <a:effectLst/>
-        </p:spPr>
-        <p:style>
-          <a:lnRef idx="1">
-            <a:schemeClr val="accent1"/>
-          </a:lnRef>
-          <a:fillRef idx="3">
-            <a:schemeClr val="accent1"/>
-          </a:fillRef>
-          <a:effectRef idx="2">
-            <a:schemeClr val="accent1"/>
-          </a:effectRef>
-          <a:fontRef idx="minor">
-            <a:schemeClr val="lt1"/>
-          </a:fontRef>
-        </p:style>
-        <p:txBody>
-          <a:bodyPr rtlCol="0" anchor="ctr" wrap="square"/>
-          <a:lstStyle/>
-          <a:p>
-            <a:pPr algn="ctr"/>
-          </a:p>
-        </p:txBody>
-      </p:sp>
-      <p:sp>
-        <p:nvSpPr>
-          <p:cNvPr id="10" name="TextBox 9"/>
-          <p:cNvSpPr txBox="1"/>
-          <p:nvPr/>
-        </p:nvSpPr>
-        <p:spPr>
-          <a:xfrm>
-            <a:off x="1463040" y="1399032"/>
-            <a:ext cx="9875519" cy="731520"/>
-          </a:xfrm>
-          <a:prstGeom prst="rect">
-            <a:avLst/>
-          </a:prstGeom>
-          <a:noFill/>
-        </p:spPr>
-        <p:txBody>
-          <a:bodyPr wrap="square" anchor="t" lIns="0" rIns="0" tIns="0" bIns="0">
-            <a:spAutoFit/>
-          </a:bodyPr>
-          <a:lstStyle/>
-          <a:p>
-            <a:pPr algn="l">
-              <a:lnSpc>
-                <a:spcPct val="100000"/>
-              </a:lnSpc>
-              <a:spcBef>
-                <a:spcPts val="0"/>
-              </a:spcBef>
-              <a:spcAft>
-                <a:spcPts val="400"/>
-              </a:spcAft>
-            </a:pPr>
-            <a:r>
-              <a:rPr sz="1700" b="1" i="0">
-                <a:solidFill>
-                  <a:srgbClr val="12275D"/>
-                </a:solidFill>
-                <a:latin typeface="Arial"/>
-              </a:rPr>
-              <a:t>Đội phát triển ADAS / AV</a:t>
-            </a:r>
-          </a:p>
-          <a:p>
-            <a:pPr algn="l">
-              <a:lnSpc>
-                <a:spcPct val="100000"/>
-              </a:lnSpc>
-              <a:spcBef>
-                <a:spcPts val="0"/>
-              </a:spcBef>
-              <a:spcAft>
-                <a:spcPts val="0"/>
-              </a:spcAft>
-            </a:pPr>
-            <a:r>
-              <a:rPr sz="1400" b="0" i="0">
-                <a:solidFill>
-                  <a:srgbClr val="5A6472"/>
-                </a:solidFill>
-                <a:latin typeface="Arial"/>
-              </a:rPr>
-              <a:t>Cần tình huống hiếm để thử controller trước khi ra đường thật.</a:t>
-            </a:r>
-          </a:p>
-        </p:txBody>
-      </p:sp>
-      <p:sp>
-        <p:nvSpPr>
-          <p:cNvPr id="11" name="Rectangle 10"/>
-          <p:cNvSpPr/>
-          <p:nvPr/>
-        </p:nvSpPr>
-        <p:spPr>
-          <a:xfrm>
-            <a:off x="1188720" y="2423160"/>
-            <a:ext cx="10424159" cy="1005840"/>
-          </a:xfrm>
-          <a:prstGeom prst="rect">
-            <a:avLst/>
-          </a:prstGeom>
-          <a:solidFill>
-            <a:srgbClr val="F2F4F8"/>
-          </a:solidFill>
-          <a:ln w="9525">
-            <a:solidFill>
-              <a:srgbClr val="D5DAE4"/>
-            </a:solidFill>
-          </a:ln>
-          <a:effectLst/>
-        </p:spPr>
-        <p:style>
-          <a:lnRef idx="1">
-            <a:schemeClr val="accent1"/>
-          </a:lnRef>
-          <a:fillRef idx="3">
-            <a:schemeClr val="accent1"/>
-          </a:fillRef>
-          <a:effectRef idx="2">
-            <a:schemeClr val="accent1"/>
-          </a:effectRef>
-          <a:fontRef idx="minor">
-            <a:schemeClr val="lt1"/>
-          </a:fontRef>
-        </p:style>
-        <p:txBody>
-          <a:bodyPr rtlCol="0" anchor="ctr" wrap="square"/>
-          <a:lstStyle/>
-          <a:p>
-            <a:pPr algn="ctr"/>
-          </a:p>
-        </p:txBody>
-      </p:sp>
-      <p:sp>
-        <p:nvSpPr>
-          <p:cNvPr id="12" name="TextBox 11"/>
-          <p:cNvSpPr txBox="1"/>
-          <p:nvPr/>
-        </p:nvSpPr>
-        <p:spPr>
-          <a:xfrm>
-            <a:off x="1463040" y="2587752"/>
-            <a:ext cx="9875519" cy="731520"/>
-          </a:xfrm>
-          <a:prstGeom prst="rect">
-            <a:avLst/>
-          </a:prstGeom>
-          <a:noFill/>
-        </p:spPr>
-        <p:txBody>
-          <a:bodyPr wrap="square" anchor="t" lIns="0" rIns="0" tIns="0" bIns="0">
-            <a:spAutoFit/>
-          </a:bodyPr>
-          <a:lstStyle/>
-          <a:p>
-            <a:pPr algn="l">
-              <a:lnSpc>
-                <a:spcPct val="100000"/>
-              </a:lnSpc>
-              <a:spcBef>
-                <a:spcPts val="0"/>
-              </a:spcBef>
-              <a:spcAft>
-                <a:spcPts val="400"/>
-              </a:spcAft>
-            </a:pPr>
-            <a:r>
-              <a:rPr sz="1700" b="1" i="0">
-                <a:solidFill>
-                  <a:srgbClr val="12275D"/>
-                </a:solidFill>
-                <a:latin typeface="Arial"/>
-              </a:rPr>
-              <a:t>Đội kiểm thử &amp; QA mô phỏng</a:t>
-            </a:r>
-          </a:p>
-          <a:p>
-            <a:pPr algn="l">
-              <a:lnSpc>
-                <a:spcPct val="100000"/>
-              </a:lnSpc>
-              <a:spcBef>
-                <a:spcPts val="0"/>
-              </a:spcBef>
-              <a:spcAft>
-                <a:spcPts val="0"/>
-              </a:spcAft>
-            </a:pPr>
-            <a:r>
-              <a:rPr sz="1400" b="0" i="0">
-                <a:solidFill>
-                  <a:srgbClr val="5A6472"/>
-                </a:solidFill>
-                <a:latin typeface="Arial"/>
-              </a:rPr>
-              <a:t>Viết và sửa .xosc thủ công tốn thời gian, nhất là phần làn đường, trigger và validation.</a:t>
-            </a:r>
-          </a:p>
-        </p:txBody>
-      </p:sp>
-      <p:sp>
-        <p:nvSpPr>
-          <p:cNvPr id="13" name="Rectangle 12"/>
-          <p:cNvSpPr/>
-          <p:nvPr/>
-        </p:nvSpPr>
-        <p:spPr>
-          <a:xfrm>
-            <a:off x="1188720" y="3611880"/>
-            <a:ext cx="10424159" cy="1005840"/>
-          </a:xfrm>
-          <a:prstGeom prst="rect">
-            <a:avLst/>
-          </a:prstGeom>
-          <a:solidFill>
-            <a:srgbClr val="F2F4F8"/>
-          </a:solidFill>
-          <a:ln w="9525">
-            <a:solidFill>
-              <a:srgbClr val="D5DAE4"/>
-            </a:solidFill>
-          </a:ln>
-          <a:effectLst/>
-        </p:spPr>
-        <p:style>
-          <a:lnRef idx="1">
-            <a:schemeClr val="accent1"/>
-          </a:lnRef>
-          <a:fillRef idx="3">
-            <a:schemeClr val="accent1"/>
-          </a:fillRef>
-          <a:effectRef idx="2">
-            <a:schemeClr val="accent1"/>
-          </a:effectRef>
-          <a:fontRef idx="minor">
-            <a:schemeClr val="lt1"/>
-          </a:fontRef>
-        </p:style>
-        <p:txBody>
-          <a:bodyPr rtlCol="0" anchor="ctr" wrap="square"/>
-          <a:lstStyle/>
-          <a:p>
-            <a:pPr algn="ctr"/>
-          </a:p>
-        </p:txBody>
-      </p:sp>
-      <p:sp>
-        <p:nvSpPr>
-          <p:cNvPr id="14" name="TextBox 13"/>
-          <p:cNvSpPr txBox="1"/>
-          <p:nvPr/>
-        </p:nvSpPr>
-        <p:spPr>
-          <a:xfrm>
-            <a:off x="1463040" y="3776472"/>
-            <a:ext cx="9875519" cy="731520"/>
-          </a:xfrm>
-          <a:prstGeom prst="rect">
-            <a:avLst/>
-          </a:prstGeom>
-          <a:noFill/>
-        </p:spPr>
-        <p:txBody>
-          <a:bodyPr wrap="square" anchor="t" lIns="0" rIns="0" tIns="0" bIns="0">
-            <a:spAutoFit/>
-          </a:bodyPr>
-          <a:lstStyle/>
-          <a:p>
-            <a:pPr algn="l">
-              <a:lnSpc>
-                <a:spcPct val="100000"/>
-              </a:lnSpc>
-              <a:spcBef>
-                <a:spcPts val="0"/>
-              </a:spcBef>
-              <a:spcAft>
-                <a:spcPts val="400"/>
-              </a:spcAft>
-            </a:pPr>
-            <a:r>
-              <a:rPr sz="1700" b="1" i="0">
-                <a:solidFill>
-                  <a:srgbClr val="12275D"/>
-                </a:solidFill>
-                <a:latin typeface="Arial"/>
-              </a:rPr>
-              <a:t>Lab &amp; trường kỹ thuật</a:t>
-            </a:r>
-          </a:p>
-          <a:p>
-            <a:pPr algn="l">
-              <a:lnSpc>
-                <a:spcPct val="100000"/>
-              </a:lnSpc>
-              <a:spcBef>
-                <a:spcPts val="0"/>
-              </a:spcBef>
-              <a:spcAft>
-                <a:spcPts val="0"/>
-              </a:spcAft>
-            </a:pPr>
-            <a:r>
-              <a:rPr sz="1400" b="0" i="0">
-                <a:solidFill>
-                  <a:srgbClr val="5A6472"/>
-                </a:solidFill>
-                <a:latin typeface="Arial"/>
-              </a:rPr>
-              <a:t>Cần bộ kịch bản có thể tái lập để so sánh giữa các nghiên cứu.</a:t>
-            </a:r>
-          </a:p>
-        </p:txBody>
-      </p:sp>
-      <p:sp>
-        <p:nvSpPr>
-          <p:cNvPr id="15" name="Rectangle 14"/>
-          <p:cNvSpPr/>
-          <p:nvPr/>
-        </p:nvSpPr>
-        <p:spPr>
-          <a:xfrm>
-            <a:off x="1188720" y="4892040"/>
-            <a:ext cx="10424159" cy="1188720"/>
-          </a:xfrm>
-          <a:prstGeom prst="rect">
-            <a:avLst/>
-          </a:prstGeom>
-          <a:solidFill>
-            <a:srgbClr val="FFFFFF"/>
-          </a:solidFill>
-          <a:ln w="15875">
-            <a:solidFill>
-              <a:srgbClr val="2F62B8"/>
-            </a:solidFill>
-          </a:ln>
-          <a:effectLst/>
-        </p:spPr>
-        <p:style>
-          <a:lnRef idx="1">
-            <a:schemeClr val="accent1"/>
-          </a:lnRef>
-          <a:fillRef idx="3">
-            <a:schemeClr val="accent1"/>
-          </a:fillRef>
-          <a:effectRef idx="2">
-            <a:schemeClr val="accent1"/>
-          </a:effectRef>
-          <a:fontRef idx="minor">
-            <a:schemeClr val="lt1"/>
-          </a:fontRef>
-        </p:style>
-        <p:txBody>
-          <a:bodyPr rtlCol="0" anchor="ctr" wrap="square"/>
-          <a:lstStyle/>
-          <a:p>
-            <a:pPr algn="ctr"/>
-          </a:p>
-        </p:txBody>
-      </p:sp>
-      <p:sp>
-        <p:nvSpPr>
-          <p:cNvPr id="16" name="TextBox 15"/>
-          <p:cNvSpPr txBox="1"/>
-          <p:nvPr/>
-        </p:nvSpPr>
-        <p:spPr>
-          <a:xfrm>
-            <a:off x="1463040" y="5074920"/>
-            <a:ext cx="9875519" cy="914400"/>
-          </a:xfrm>
-          <a:prstGeom prst="rect">
-            <a:avLst/>
-          </a:prstGeom>
-          <a:noFill/>
-        </p:spPr>
-        <p:txBody>
-          <a:bodyPr wrap="square" anchor="t" lIns="0" rIns="0" tIns="0" bIns="0">
-            <a:spAutoFit/>
-          </a:bodyPr>
-          <a:lstStyle/>
-          <a:p>
-            <a:pPr algn="l">
-              <a:lnSpc>
-                <a:spcPct val="100000"/>
-              </a:lnSpc>
-              <a:spcBef>
-                <a:spcPts val="0"/>
-              </a:spcBef>
-              <a:spcAft>
-                <a:spcPts val="600"/>
-              </a:spcAft>
-            </a:pPr>
-            <a:r>
-              <a:rPr sz="1800" b="1" i="0">
-                <a:solidFill>
-                  <a:srgbClr val="12275D"/>
-                </a:solidFill>
-                <a:latin typeface="Arial"/>
-              </a:rPr>
-              <a:t>Điểm bán thật không phải “AI sinh XML”.</a:t>
-            </a:r>
-          </a:p>
-          <a:p>
-            <a:pPr algn="l">
-              <a:lnSpc>
-                <a:spcPct val="120000"/>
-              </a:lnSpc>
-              <a:spcBef>
-                <a:spcPts val="0"/>
-              </a:spcBef>
-              <a:spcAft>
-                <a:spcPts val="0"/>
-              </a:spcAft>
-            </a:pPr>
-            <a:r>
-              <a:rPr sz="1500" b="0" i="0">
-                <a:solidFill>
-                  <a:srgbClr val="5A6472"/>
-                </a:solidFill>
-                <a:latin typeface="Arial"/>
-              </a:rPr>
-              <a:t>Là một thư viện kịch bản mà mỗi mục đều có bằng chứng CARLA và chữ ký người duyệt đứng sau. Sinh nhanh thì ai cũng làm được; sinh mà tin được thì phải có hai cổng kia.</a:t>
-            </a:r>
-          </a:p>
-        </p:txBody>
-      </p:sp>
-    </p:spTree>
-  </p:cSld>
-  <p:clrMapOvr>
-    <a:masterClrMapping/>
-  </p:clrMapOvr>
-</p:sld>
-</file>
-
-<file path=ppt/slides/slide15.xml><?xml version="1.0" encoding="utf-8"?>
-<p:sld xmlns:a="http://schemas.openxmlformats.org/drawingml/2006/main" xmlns:p="http://schemas.openxmlformats.org/presentationml/2006/main" xmlns:r="http://schemas.openxmlformats.org/officeDocument/2006/relationships">
-  <p:cSld>
-    <p:spTree>
-      <p:nvGrpSpPr>
-        <p:cNvPr id="1" name=""/>
-        <p:cNvGrpSpPr/>
-        <p:nvPr/>
-      </p:nvGrpSpPr>
-      <p:grpSpPr/>
-      <p:sp>
-        <p:nvSpPr>
-          <p:cNvPr id="2" name="Rectangle 1"/>
-          <p:cNvSpPr/>
-          <p:nvPr/>
-        </p:nvSpPr>
-        <p:spPr>
-          <a:xfrm>
-            <a:off x="0" y="0"/>
-            <a:ext cx="777240" cy="6858000"/>
-          </a:xfrm>
-          <a:prstGeom prst="rect">
-            <a:avLst/>
-          </a:prstGeom>
-          <a:solidFill>
-            <a:srgbClr val="12275D"/>
-          </a:solidFill>
-          <a:ln>
-            <a:noFill/>
-          </a:ln>
-          <a:effectLst/>
-        </p:spPr>
-        <p:style>
-          <a:lnRef idx="1">
-            <a:schemeClr val="accent1"/>
-          </a:lnRef>
-          <a:fillRef idx="3">
-            <a:schemeClr val="accent1"/>
-          </a:fillRef>
-          <a:effectRef idx="2">
-            <a:schemeClr val="accent1"/>
-          </a:effectRef>
-          <a:fontRef idx="minor">
-            <a:schemeClr val="lt1"/>
-          </a:fontRef>
-        </p:style>
-        <p:txBody>
-          <a:bodyPr rtlCol="0" anchor="ctr" wrap="square"/>
-          <a:lstStyle/>
-          <a:p>
-            <a:pPr algn="ctr"/>
-          </a:p>
-        </p:txBody>
-      </p:sp>
-      <p:sp>
-        <p:nvSpPr>
-          <p:cNvPr id="3" name="TextBox 2"/>
-          <p:cNvSpPr txBox="1"/>
-          <p:nvPr/>
-        </p:nvSpPr>
-        <p:spPr>
-          <a:xfrm rot="16200000">
-            <a:off x="-1623060" y="3154680"/>
-            <a:ext cx="4023360" cy="548640"/>
-          </a:xfrm>
-          <a:prstGeom prst="rect">
-            <a:avLst/>
-          </a:prstGeom>
-          <a:noFill/>
-        </p:spPr>
-        <p:txBody>
-          <a:bodyPr wrap="none" anchor="ctr">
-            <a:spAutoFit/>
-          </a:bodyPr>
-          <a:lstStyle/>
-          <a:p>
-            <a:pPr algn="ctr"/>
-            <a:r>
-              <a:rPr sz="1800" b="1">
-                <a:solidFill>
-                  <a:srgbClr val="FFFFFF"/>
-                </a:solidFill>
-                <a:latin typeface="Arial"/>
-              </a:rPr>
-              <a:t>Tiếp theo</a:t>
-            </a:r>
-          </a:p>
-        </p:txBody>
-      </p:sp>
-      <p:sp>
-        <p:nvSpPr>
-          <p:cNvPr id="4" name="TextBox 3"/>
-          <p:cNvSpPr txBox="1"/>
-          <p:nvPr/>
-        </p:nvSpPr>
-        <p:spPr>
-          <a:xfrm>
-            <a:off x="1188720" y="274320"/>
-            <a:ext cx="8778240" cy="457200"/>
-          </a:xfrm>
-          <a:prstGeom prst="rect">
-            <a:avLst/>
-          </a:prstGeom>
-          <a:noFill/>
-        </p:spPr>
-        <p:txBody>
-          <a:bodyPr wrap="square" anchor="t" lIns="0" rIns="0" tIns="0" bIns="0">
-            <a:spAutoFit/>
-          </a:bodyPr>
-          <a:lstStyle/>
-          <a:p>
-            <a:pPr algn="l">
-              <a:lnSpc>
-                <a:spcPct val="100000"/>
-              </a:lnSpc>
-              <a:spcBef>
-                <a:spcPts val="0"/>
-              </a:spcBef>
-              <a:spcAft>
-                <a:spcPts val="0"/>
-              </a:spcAft>
-            </a:pPr>
-            <a:r>
-              <a:rPr sz="2400" b="1" i="0">
-                <a:solidFill>
-                  <a:srgbClr val="12275D"/>
-                </a:solidFill>
-                <a:latin typeface="Arial"/>
-              </a:rPr>
-              <a:t>Làm gì tiếp</a:t>
-            </a:r>
-          </a:p>
-        </p:txBody>
-      </p:sp>
-      <p:sp>
-        <p:nvSpPr>
-          <p:cNvPr id="5" name="Rectangle 4"/>
-          <p:cNvSpPr/>
-          <p:nvPr/>
-        </p:nvSpPr>
-        <p:spPr>
-          <a:xfrm>
-            <a:off x="1170432" y="786384"/>
-            <a:ext cx="9107424" cy="50292"/>
-          </a:xfrm>
-          <a:prstGeom prst="rect">
-            <a:avLst/>
-          </a:prstGeom>
-          <a:solidFill>
-            <a:srgbClr val="12275D"/>
-          </a:solidFill>
-          <a:ln>
-            <a:noFill/>
-          </a:ln>
-          <a:effectLst/>
-        </p:spPr>
-        <p:style>
-          <a:lnRef idx="1">
-            <a:schemeClr val="accent1"/>
-          </a:lnRef>
-          <a:fillRef idx="3">
-            <a:schemeClr val="accent1"/>
-          </a:fillRef>
-          <a:effectRef idx="2">
-            <a:schemeClr val="accent1"/>
-          </a:effectRef>
-          <a:fontRef idx="minor">
-            <a:schemeClr val="lt1"/>
-          </a:fontRef>
-        </p:style>
-        <p:txBody>
-          <a:bodyPr rtlCol="0" anchor="ctr" wrap="square"/>
-          <a:lstStyle/>
-          <a:p>
-            <a:pPr algn="ctr"/>
-          </a:p>
-        </p:txBody>
-      </p:sp>
-      <p:sp>
-        <p:nvSpPr>
-          <p:cNvPr id="6" name="Rectangle 5"/>
-          <p:cNvSpPr/>
-          <p:nvPr/>
-        </p:nvSpPr>
-        <p:spPr>
-          <a:xfrm>
-            <a:off x="10552176" y="786384"/>
-            <a:ext cx="1042415" cy="50292"/>
-          </a:xfrm>
-          <a:prstGeom prst="rect">
-            <a:avLst/>
-          </a:prstGeom>
-          <a:solidFill>
-            <a:srgbClr val="E06C1F"/>
-          </a:solidFill>
-          <a:ln>
-            <a:noFill/>
-          </a:ln>
-          <a:effectLst/>
-        </p:spPr>
-        <p:style>
-          <a:lnRef idx="1">
-            <a:schemeClr val="accent1"/>
-          </a:lnRef>
-          <a:fillRef idx="3">
-            <a:schemeClr val="accent1"/>
-          </a:fillRef>
-          <a:effectRef idx="2">
-            <a:schemeClr val="accent1"/>
-          </a:effectRef>
-          <a:fontRef idx="minor">
-            <a:schemeClr val="lt1"/>
-          </a:fontRef>
-        </p:style>
-        <p:txBody>
-          <a:bodyPr rtlCol="0" anchor="ctr" wrap="square"/>
-          <a:lstStyle/>
-          <a:p>
-            <a:pPr algn="ctr"/>
-          </a:p>
-        </p:txBody>
-      </p:sp>
-      <p:sp>
-        <p:nvSpPr>
-          <p:cNvPr id="7" name="TextBox 6"/>
-          <p:cNvSpPr txBox="1"/>
-          <p:nvPr/>
-        </p:nvSpPr>
-        <p:spPr>
-          <a:xfrm>
-            <a:off x="9418320" y="310896"/>
-            <a:ext cx="2176272" cy="310896"/>
-          </a:xfrm>
-          <a:prstGeom prst="rect">
-            <a:avLst/>
-          </a:prstGeom>
-          <a:noFill/>
-        </p:spPr>
-        <p:txBody>
-          <a:bodyPr wrap="square" anchor="ctr" lIns="0" rIns="0" tIns="0" bIns="0">
-            <a:spAutoFit/>
-          </a:bodyPr>
-          <a:lstStyle/>
-          <a:p>
-            <a:pPr algn="r">
-              <a:lnSpc>
-                <a:spcPct val="100000"/>
-              </a:lnSpc>
-              <a:spcBef>
-                <a:spcPts val="0"/>
-              </a:spcBef>
-              <a:spcAft>
-                <a:spcPts val="0"/>
-              </a:spcAft>
-            </a:pPr>
-            <a:r>
-              <a:rPr sz="1100" b="0" i="0">
-                <a:solidFill>
-                  <a:srgbClr val="5A6472"/>
-                </a:solidFill>
-                <a:latin typeface="Arial"/>
-              </a:rPr>
-              <a:t>Scenario Forge · P-130</a:t>
-            </a:r>
-          </a:p>
-        </p:txBody>
-      </p:sp>
-      <p:sp>
-        <p:nvSpPr>
-          <p:cNvPr id="8" name="TextBox 7"/>
-          <p:cNvSpPr txBox="1"/>
-          <p:nvPr/>
-        </p:nvSpPr>
-        <p:spPr>
-          <a:xfrm>
-            <a:off x="11064240" y="6400800"/>
-            <a:ext cx="548640" cy="274320"/>
-          </a:xfrm>
-          <a:prstGeom prst="rect">
-            <a:avLst/>
-          </a:prstGeom>
-          <a:noFill/>
-        </p:spPr>
-        <p:txBody>
-          <a:bodyPr wrap="square" anchor="b" lIns="0" rIns="0" tIns="0" bIns="0">
-            <a:spAutoFit/>
-          </a:bodyPr>
-          <a:lstStyle/>
-          <a:p>
-            <a:pPr algn="r">
-              <a:lnSpc>
-                <a:spcPct val="100000"/>
-              </a:lnSpc>
-              <a:spcBef>
-                <a:spcPts val="0"/>
-              </a:spcBef>
-              <a:spcAft>
-                <a:spcPts val="0"/>
-              </a:spcAft>
-            </a:pPr>
-            <a:r>
-              <a:rPr sz="1100" b="0" i="0">
-                <a:solidFill>
-                  <a:srgbClr val="5A6472"/>
-                </a:solidFill>
-                <a:latin typeface="Arial"/>
-              </a:rPr>
-              <a:t>15</a:t>
             </a:r>
           </a:p>
         </p:txBody>

</xml_diff>

<commit_message>
docs: bỏ hàng 4 con số ở slide đầu
Bốn con số đó không đọc được ở giây thứ 0: người xem chưa biết M3 hay oracle
là gì. Chúng đã được trình bày kèm ngữ cảnh ở slide 9-13.

Hai trong bốn còn đang sai sau khi slide 12 chuyển sang số 29/08 (2,77s và
$0,0023 so với 3,510s và $0,002988), nên deck đang tự mâu thuẫn.

Slide đầu còn tiêu đề, một dòng giá trị, một câu mô tả và dòng link.
</commit_message>
<xml_diff>
--- a/presentation/pitch_deck.pptx
+++ b/presentation/pitch_deck.pptx
@@ -5376,7 +5376,7 @@
         </p:nvSpPr>
         <p:spPr>
           <a:xfrm>
-            <a:off x="1188720" y="2971800"/>
+            <a:off x="1188720" y="3429000"/>
             <a:ext cx="10058400" cy="1097280"/>
           </a:xfrm>
           <a:prstGeom prst="rect">
@@ -5415,459 +5415,7 @@
       </p:sp>
       <p:sp>
         <p:nvSpPr>
-          <p:cNvPr id="6" name="Rectangle 5"/>
-          <p:cNvSpPr/>
-          <p:nvPr/>
-        </p:nvSpPr>
-        <p:spPr>
-          <a:xfrm>
-            <a:off x="1188720" y="4251960"/>
-            <a:ext cx="2304288" cy="1005840"/>
-          </a:xfrm>
-          <a:prstGeom prst="rect">
-            <a:avLst/>
-          </a:prstGeom>
-          <a:solidFill>
-            <a:srgbClr val="F2F4F8"/>
-          </a:solidFill>
-          <a:ln w="9525">
-            <a:solidFill>
-              <a:srgbClr val="D5DAE4"/>
-            </a:solidFill>
-          </a:ln>
-          <a:effectLst/>
-        </p:spPr>
-        <p:style>
-          <a:lnRef idx="1">
-            <a:schemeClr val="accent1"/>
-          </a:lnRef>
-          <a:fillRef idx="3">
-            <a:schemeClr val="accent1"/>
-          </a:fillRef>
-          <a:effectRef idx="2">
-            <a:schemeClr val="accent1"/>
-          </a:effectRef>
-          <a:fontRef idx="minor">
-            <a:schemeClr val="lt1"/>
-          </a:fontRef>
-        </p:style>
-        <p:txBody>
-          <a:bodyPr rtlCol="0" anchor="ctr" wrap="square"/>
-          <a:lstStyle/>
-          <a:p>
-            <a:pPr algn="ctr"/>
-          </a:p>
-        </p:txBody>
-      </p:sp>
-      <p:sp>
-        <p:nvSpPr>
-          <p:cNvPr id="7" name="TextBox 6"/>
-          <p:cNvSpPr txBox="1"/>
-          <p:nvPr/>
-        </p:nvSpPr>
-        <p:spPr>
-          <a:xfrm>
-            <a:off x="1335024" y="4398264"/>
-            <a:ext cx="2011680" cy="713232"/>
-          </a:xfrm>
-          <a:prstGeom prst="rect">
-            <a:avLst/>
-          </a:prstGeom>
-          <a:noFill/>
-        </p:spPr>
-        <p:txBody>
-          <a:bodyPr wrap="square" anchor="t" lIns="0" rIns="0" tIns="0" bIns="0">
-            <a:spAutoFit/>
-          </a:bodyPr>
-          <a:lstStyle/>
-          <a:p>
-            <a:pPr algn="l">
-              <a:lnSpc>
-                <a:spcPct val="100000"/>
-              </a:lnSpc>
-              <a:spcBef>
-                <a:spcPts val="0"/>
-              </a:spcBef>
-              <a:spcAft>
-                <a:spcPts val="200"/>
-              </a:spcAft>
-            </a:pPr>
-            <a:r>
-              <a:rPr sz="2600" b="1" i="0">
-                <a:solidFill>
-                  <a:srgbClr val="2F62B8"/>
-                </a:solidFill>
-                <a:latin typeface="Arial"/>
-              </a:rPr>
-              <a:t>60,00%</a:t>
-            </a:r>
-          </a:p>
-          <a:p>
-            <a:pPr algn="l">
-              <a:lnSpc>
-                <a:spcPct val="105000"/>
-              </a:lnSpc>
-              <a:spcBef>
-                <a:spcPts val="0"/>
-              </a:spcBef>
-              <a:spcAft>
-                <a:spcPts val="0"/>
-              </a:spcAft>
-            </a:pPr>
-            <a:r>
-              <a:rPr sz="1200" b="0" i="0">
-                <a:solidFill>
-                  <a:srgbClr val="5A6472"/>
-                </a:solidFill>
-                <a:latin typeface="Arial"/>
-              </a:rPr>
-              <a:t>lượt chạy có nguy hiểm</a:t>
-            </a:r>
-          </a:p>
-        </p:txBody>
-      </p:sp>
-      <p:sp>
-        <p:nvSpPr>
-          <p:cNvPr id="8" name="Rectangle 7"/>
-          <p:cNvSpPr/>
-          <p:nvPr/>
-        </p:nvSpPr>
-        <p:spPr>
-          <a:xfrm>
-            <a:off x="3675888" y="4251960"/>
-            <a:ext cx="2304288" cy="1005840"/>
-          </a:xfrm>
-          <a:prstGeom prst="rect">
-            <a:avLst/>
-          </a:prstGeom>
-          <a:solidFill>
-            <a:srgbClr val="F2F4F8"/>
-          </a:solidFill>
-          <a:ln w="9525">
-            <a:solidFill>
-              <a:srgbClr val="D5DAE4"/>
-            </a:solidFill>
-          </a:ln>
-          <a:effectLst/>
-        </p:spPr>
-        <p:style>
-          <a:lnRef idx="1">
-            <a:schemeClr val="accent1"/>
-          </a:lnRef>
-          <a:fillRef idx="3">
-            <a:schemeClr val="accent1"/>
-          </a:fillRef>
-          <a:effectRef idx="2">
-            <a:schemeClr val="accent1"/>
-          </a:effectRef>
-          <a:fontRef idx="minor">
-            <a:schemeClr val="lt1"/>
-          </a:fontRef>
-        </p:style>
-        <p:txBody>
-          <a:bodyPr rtlCol="0" anchor="ctr" wrap="square"/>
-          <a:lstStyle/>
-          <a:p>
-            <a:pPr algn="ctr"/>
-          </a:p>
-        </p:txBody>
-      </p:sp>
-      <p:sp>
-        <p:nvSpPr>
-          <p:cNvPr id="9" name="TextBox 8"/>
-          <p:cNvSpPr txBox="1"/>
-          <p:nvPr/>
-        </p:nvSpPr>
-        <p:spPr>
-          <a:xfrm>
-            <a:off x="3822192" y="4398264"/>
-            <a:ext cx="2011680" cy="713232"/>
-          </a:xfrm>
-          <a:prstGeom prst="rect">
-            <a:avLst/>
-          </a:prstGeom>
-          <a:noFill/>
-        </p:spPr>
-        <p:txBody>
-          <a:bodyPr wrap="square" anchor="t" lIns="0" rIns="0" tIns="0" bIns="0">
-            <a:spAutoFit/>
-          </a:bodyPr>
-          <a:lstStyle/>
-          <a:p>
-            <a:pPr algn="l">
-              <a:lnSpc>
-                <a:spcPct val="100000"/>
-              </a:lnSpc>
-              <a:spcBef>
-                <a:spcPts val="0"/>
-              </a:spcBef>
-              <a:spcAft>
-                <a:spcPts val="200"/>
-              </a:spcAft>
-            </a:pPr>
-            <a:r>
-              <a:rPr sz="2600" b="1" i="0">
-                <a:solidFill>
-                  <a:srgbClr val="2F62B8"/>
-                </a:solidFill>
-                <a:latin typeface="Arial"/>
-              </a:rPr>
-              <a:t>$0,0023</a:t>
-            </a:r>
-          </a:p>
-          <a:p>
-            <a:pPr algn="l">
-              <a:lnSpc>
-                <a:spcPct val="105000"/>
-              </a:lnSpc>
-              <a:spcBef>
-                <a:spcPts val="0"/>
-              </a:spcBef>
-              <a:spcAft>
-                <a:spcPts val="0"/>
-              </a:spcAft>
-            </a:pPr>
-            <a:r>
-              <a:rPr sz="1200" b="0" i="0">
-                <a:solidFill>
-                  <a:srgbClr val="5A6472"/>
-                </a:solidFill>
-                <a:latin typeface="Arial"/>
-              </a:rPr>
-              <a:t>chi phí trung vị / request</a:t>
-            </a:r>
-          </a:p>
-        </p:txBody>
-      </p:sp>
-      <p:sp>
-        <p:nvSpPr>
-          <p:cNvPr id="10" name="Rectangle 9"/>
-          <p:cNvSpPr/>
-          <p:nvPr/>
-        </p:nvSpPr>
-        <p:spPr>
-          <a:xfrm>
-            <a:off x="6163056" y="4251960"/>
-            <a:ext cx="2304288" cy="1005840"/>
-          </a:xfrm>
-          <a:prstGeom prst="rect">
-            <a:avLst/>
-          </a:prstGeom>
-          <a:solidFill>
-            <a:srgbClr val="F2F4F8"/>
-          </a:solidFill>
-          <a:ln w="9525">
-            <a:solidFill>
-              <a:srgbClr val="D5DAE4"/>
-            </a:solidFill>
-          </a:ln>
-          <a:effectLst/>
-        </p:spPr>
-        <p:style>
-          <a:lnRef idx="1">
-            <a:schemeClr val="accent1"/>
-          </a:lnRef>
-          <a:fillRef idx="3">
-            <a:schemeClr val="accent1"/>
-          </a:fillRef>
-          <a:effectRef idx="2">
-            <a:schemeClr val="accent1"/>
-          </a:effectRef>
-          <a:fontRef idx="minor">
-            <a:schemeClr val="lt1"/>
-          </a:fontRef>
-        </p:style>
-        <p:txBody>
-          <a:bodyPr rtlCol="0" anchor="ctr" wrap="square"/>
-          <a:lstStyle/>
-          <a:p>
-            <a:pPr algn="ctr"/>
-          </a:p>
-        </p:txBody>
-      </p:sp>
-      <p:sp>
-        <p:nvSpPr>
-          <p:cNvPr id="11" name="TextBox 10"/>
-          <p:cNvSpPr txBox="1"/>
-          <p:nvPr/>
-        </p:nvSpPr>
-        <p:spPr>
-          <a:xfrm>
-            <a:off x="6309360" y="4398264"/>
-            <a:ext cx="2011680" cy="713232"/>
-          </a:xfrm>
-          <a:prstGeom prst="rect">
-            <a:avLst/>
-          </a:prstGeom>
-          <a:noFill/>
-        </p:spPr>
-        <p:txBody>
-          <a:bodyPr wrap="square" anchor="t" lIns="0" rIns="0" tIns="0" bIns="0">
-            <a:spAutoFit/>
-          </a:bodyPr>
-          <a:lstStyle/>
-          <a:p>
-            <a:pPr algn="l">
-              <a:lnSpc>
-                <a:spcPct val="100000"/>
-              </a:lnSpc>
-              <a:spcBef>
-                <a:spcPts val="0"/>
-              </a:spcBef>
-              <a:spcAft>
-                <a:spcPts val="200"/>
-              </a:spcAft>
-            </a:pPr>
-            <a:r>
-              <a:rPr sz="2600" b="1" i="0">
-                <a:solidFill>
-                  <a:srgbClr val="2F62B8"/>
-                </a:solidFill>
-                <a:latin typeface="Arial"/>
-              </a:rPr>
-              <a:t>2,77 s</a:t>
-            </a:r>
-          </a:p>
-          <a:p>
-            <a:pPr algn="l">
-              <a:lnSpc>
-                <a:spcPct val="105000"/>
-              </a:lnSpc>
-              <a:spcBef>
-                <a:spcPts val="0"/>
-              </a:spcBef>
-              <a:spcAft>
-                <a:spcPts val="0"/>
-              </a:spcAft>
-            </a:pPr>
-            <a:r>
-              <a:rPr sz="1200" b="0" i="0">
-                <a:solidFill>
-                  <a:srgbClr val="5A6472"/>
-                </a:solidFill>
-                <a:latin typeface="Arial"/>
-              </a:rPr>
-              <a:t>latency p50 toàn workflow</a:t>
-            </a:r>
-          </a:p>
-        </p:txBody>
-      </p:sp>
-      <p:sp>
-        <p:nvSpPr>
-          <p:cNvPr id="12" name="Rectangle 11"/>
-          <p:cNvSpPr/>
-          <p:nvPr/>
-        </p:nvSpPr>
-        <p:spPr>
-          <a:xfrm>
-            <a:off x="8650224" y="4251960"/>
-            <a:ext cx="2304288" cy="1005840"/>
-          </a:xfrm>
-          <a:prstGeom prst="rect">
-            <a:avLst/>
-          </a:prstGeom>
-          <a:solidFill>
-            <a:srgbClr val="F2F4F8"/>
-          </a:solidFill>
-          <a:ln w="9525">
-            <a:solidFill>
-              <a:srgbClr val="D5DAE4"/>
-            </a:solidFill>
-          </a:ln>
-          <a:effectLst/>
-        </p:spPr>
-        <p:style>
-          <a:lnRef idx="1">
-            <a:schemeClr val="accent1"/>
-          </a:lnRef>
-          <a:fillRef idx="3">
-            <a:schemeClr val="accent1"/>
-          </a:fillRef>
-          <a:effectRef idx="2">
-            <a:schemeClr val="accent1"/>
-          </a:effectRef>
-          <a:fontRef idx="minor">
-            <a:schemeClr val="lt1"/>
-          </a:fontRef>
-        </p:style>
-        <p:txBody>
-          <a:bodyPr rtlCol="0" anchor="ctr" wrap="square"/>
-          <a:lstStyle/>
-          <a:p>
-            <a:pPr algn="ctr"/>
-          </a:p>
-        </p:txBody>
-      </p:sp>
-      <p:sp>
-        <p:nvSpPr>
-          <p:cNvPr id="13" name="TextBox 12"/>
-          <p:cNvSpPr txBox="1"/>
-          <p:nvPr/>
-        </p:nvSpPr>
-        <p:spPr>
-          <a:xfrm>
-            <a:off x="8796528" y="4398264"/>
-            <a:ext cx="2011680" cy="713232"/>
-          </a:xfrm>
-          <a:prstGeom prst="rect">
-            <a:avLst/>
-          </a:prstGeom>
-          <a:noFill/>
-        </p:spPr>
-        <p:txBody>
-          <a:bodyPr wrap="square" anchor="t" lIns="0" rIns="0" tIns="0" bIns="0">
-            <a:spAutoFit/>
-          </a:bodyPr>
-          <a:lstStyle/>
-          <a:p>
-            <a:pPr algn="l">
-              <a:lnSpc>
-                <a:spcPct val="100000"/>
-              </a:lnSpc>
-              <a:spcBef>
-                <a:spcPts val="0"/>
-              </a:spcBef>
-              <a:spcAft>
-                <a:spcPts val="200"/>
-              </a:spcAft>
-            </a:pPr>
-            <a:r>
-              <a:rPr sz="2600" b="1" i="0">
-                <a:solidFill>
-                  <a:srgbClr val="2F62B8"/>
-                </a:solidFill>
-                <a:latin typeface="Arial"/>
-              </a:rPr>
-              <a:t>6/6</a:t>
-            </a:r>
-          </a:p>
-          <a:p>
-            <a:pPr algn="l">
-              <a:lnSpc>
-                <a:spcPct val="105000"/>
-              </a:lnSpc>
-              <a:spcBef>
-                <a:spcPts val="0"/>
-              </a:spcBef>
-              <a:spcAft>
-                <a:spcPts val="0"/>
-              </a:spcAft>
-            </a:pPr>
-            <a:r>
-              <a:rPr sz="1200" b="0" i="0">
-                <a:solidFill>
-                  <a:srgbClr val="5A6472"/>
-                </a:solidFill>
-                <a:latin typeface="Arial"/>
-              </a:rPr>
-              <a:t>oracle hành vi trong phạm vi</a:t>
-            </a:r>
-          </a:p>
-        </p:txBody>
-      </p:sp>
-      <p:sp>
-        <p:nvSpPr>
-          <p:cNvPr id="14" name="TextBox 13"/>
+          <p:cNvPr id="6" name="TextBox 5"/>
           <p:cNvSpPr txBox="1"/>
           <p:nvPr/>
         </p:nvSpPr>

</xml_diff>

<commit_message>
docs: slide 11 ghi thẳng phép cộng thay vì hai phân số rời
'21/35' và 'riêng va chạm 17/35' buộc người xem tự cộng 17+4 mới hiểu 21 ở
đâu ra, trong khi thanh ngang bên cạnh đã hiện sẵn 17/4/14. Đổi thành
'17 va chạm + 4 suýt va chạm = 21/35'.
</commit_message>
<xml_diff>
--- a/presentation/pitch_deck.pptx
+++ b/presentation/pitch_deck.pptx
@@ -11238,8 +11238,8 @@
                 </a:solidFill>
                 <a:latin typeface="Arial"/>
               </a:rPr>
-              <a:t>21/35 lượt dựng được nguy hiểm
-riêng va chạm: 17/35</a:t>
+              <a:t>17 va chạm + 4 suýt va chạm
+= 21/35 lượt dựng được nguy hiểm</a:t>
             </a:r>
           </a:p>
         </p:txBody>

</xml_diff>

<commit_message>
docs: slide 8 khép vòng lặp, slide 14 đổi việc thứ ba
Slide 8 tách bước cuối thành hai: 'vẫn đâm -> giữ làm ca hồi quy' và 'chưa đủ
khó -> dò biến thể, quay lại bước 3'. Sơ đồ cũ dừng ở một dòng gộp
'keep_regression hoặc create_harder_variant', không cho thấy nhánh thứ hai
quay ngược lên trên — mà chính chỗ quay ngược đó mới là closed-loop.

Slide 14 thay 'mở rộng nhãn người' bằng 'bộ dò riêng cho vượt đèn đỏ'. Đây là
giới hạn đã đo được: bộ dò hiện vặn thời điểm kích hoạt, neo vào giây hai xe
đi ngang nhau, nên với run_red_light thì không có mốc (hai xe đi hai nhánh
vuông góc, s_offset_m = 0). Kiểm thật trên sc_046/sc_047: API trả 422 kèm lý
do. Ảnh hưởng 10/72 ô nên đáng đứng trong bốn việc tiếp theo hơn.
</commit_message>
<xml_diff>
--- a/presentation/pitch_deck.pptx
+++ b/presentation/pitch_deck.pptx
@@ -1173,17 +1173,32 @@
           <a:p/>
           <a:p>
             <a:r>
-              <a:t>Việc thứ ba: mở rộng nhãn người. Hiện em mới ngồi chấm tay mười ba lượt, chủ yếu</a:t>
-            </a:r>
-          </a:p>
-          <a:p>
-            <a:r>
-              <a:t>quanh các case lỗi đã biết. Càng nhiều nhãn thì con số bảy mươi bảy phần trăm</a:t>
-            </a:r>
-          </a:p>
-          <a:p>
-            <a:r>
-              <a:t>càng nói được nhiều về oracle.</a:t>
+              <a:t>Việc thứ ba là một giới hạn em đo được và biết rõ nguyên nhân. Bộ dò biến thể</a:t>
+            </a:r>
+          </a:p>
+          <a:p>
+            <a:r>
+              <a:t>hiện vặn thời điểm kích hoạt, neo vào giây hai xe đi ngang nhau. Với vượt đèn đỏ</a:t>
+            </a:r>
+          </a:p>
+          <a:p>
+            <a:r>
+              <a:t>thì mốc đó không tồn tại — hai xe đi trên hai nhánh vuông góc, không có khoảng</a:t>
+            </a:r>
+          </a:p>
+          <a:p>
+            <a:r>
+              <a:t>cách dọc để tính. Hệ thống từ chối dò và nói thẳng vấn đề nằm ở tốc độ ban đầu.</a:t>
+            </a:r>
+          </a:p>
+          <a:p>
+            <a:r>
+              <a:t>Lời giải là một bộ dò riêng theo thời gian mỗi xe tới điểm xung đột, và nó mở</a:t>
+            </a:r>
+          </a:p>
+          <a:p>
+            <a:r>
+              <a:t>khoá mười trong bảy mươi hai ô.</a:t>
             </a:r>
           </a:p>
           <a:p/>
@@ -14799,7 +14814,7 @@
                 </a:solidFill>
                 <a:latin typeface="Arial"/>
               </a:rPr>
-              <a:t>Mở rộng nhãn người trên từng maneuver</a:t>
+              <a:t>Bộ dò riêng cho vượt đèn đỏ</a:t>
             </a:r>
           </a:p>
           <a:p>
@@ -14821,7 +14836,7 @@
                 </a:solidFill>
                 <a:latin typeface="Arial"/>
               </a:rPr>
-              <a:t>Hiện mới chấm tay 13 lượt, tập trung vào case lỗi đã biết. Càng nhiều nhãn thì con số 76,92% càng nói được nhiều.</a:t>
+              <a:t>Bộ dò hiện vặn thời điểm nên bó tay với 10 ô vượt đèn đỏ. Ở đó phải vặn tốc độ theo thời gian tới điểm xung đột.</a:t>
             </a:r>
           </a:p>
         </p:txBody>
@@ -22501,21 +22516,109 @@
                 </a:solidFill>
                 <a:latin typeface="Arial"/>
               </a:rPr>
-              <a:t>→ keep_regression hoặc create_harder_variant</a:t>
-            </a:r>
-          </a:p>
-        </p:txBody>
-      </p:sp>
-      <p:sp>
-        <p:nvSpPr>
-          <p:cNvPr id="27" name="TextBox 26"/>
+              <a:t>vẫn đâm → giữ làm ca hồi quy</a:t>
+            </a:r>
+          </a:p>
+        </p:txBody>
+      </p:sp>
+      <p:sp>
+        <p:nvSpPr>
+          <p:cNvPr id="27" name="Down Arrow 26"/>
+          <p:cNvSpPr/>
+          <p:nvPr/>
+        </p:nvSpPr>
+        <p:spPr>
+          <a:xfrm>
+            <a:off x="3653028" y="4965192"/>
+            <a:ext cx="146304" cy="146304"/>
+          </a:xfrm>
+          <a:prstGeom prst="downArrow">
+            <a:avLst/>
+          </a:prstGeom>
+          <a:solidFill>
+            <a:srgbClr val="8A8FA6"/>
+          </a:solidFill>
+          <a:ln>
+            <a:noFill/>
+          </a:ln>
+          <a:effectLst/>
+        </p:spPr>
+        <p:style>
+          <a:lnRef idx="1">
+            <a:schemeClr val="accent1"/>
+          </a:lnRef>
+          <a:fillRef idx="3">
+            <a:schemeClr val="accent1"/>
+          </a:fillRef>
+          <a:effectRef idx="2">
+            <a:schemeClr val="accent1"/>
+          </a:effectRef>
+          <a:fontRef idx="minor">
+            <a:schemeClr val="lt1"/>
+          </a:fontRef>
+        </p:style>
+        <p:txBody>
+          <a:bodyPr rtlCol="0" anchor="ctr" wrap="square"/>
+          <a:lstStyle/>
+          <a:p>
+            <a:pPr algn="ctr"/>
+          </a:p>
+        </p:txBody>
+      </p:sp>
+      <p:sp>
+        <p:nvSpPr>
+          <p:cNvPr id="28" name="Rounded Rectangle 27"/>
+          <p:cNvSpPr/>
+          <p:nvPr/>
+        </p:nvSpPr>
+        <p:spPr>
+          <a:xfrm>
+            <a:off x="1188720" y="5120640"/>
+            <a:ext cx="5074920" cy="493776"/>
+          </a:xfrm>
+          <a:prstGeom prst="roundRect">
+            <a:avLst/>
+          </a:prstGeom>
+          <a:solidFill>
+            <a:srgbClr val="E06C1F"/>
+          </a:solidFill>
+          <a:ln>
+            <a:noFill/>
+          </a:ln>
+          <a:effectLst/>
+        </p:spPr>
+        <p:style>
+          <a:lnRef idx="1">
+            <a:schemeClr val="accent1"/>
+          </a:lnRef>
+          <a:fillRef idx="3">
+            <a:schemeClr val="accent1"/>
+          </a:fillRef>
+          <a:effectRef idx="2">
+            <a:schemeClr val="accent1"/>
+          </a:effectRef>
+          <a:fontRef idx="minor">
+            <a:schemeClr val="lt1"/>
+          </a:fontRef>
+        </p:style>
+        <p:txBody>
+          <a:bodyPr rtlCol="0" anchor="ctr" wrap="square"/>
+          <a:lstStyle/>
+          <a:p>
+            <a:pPr algn="ctr"/>
+          </a:p>
+        </p:txBody>
+      </p:sp>
+      <p:sp>
+        <p:nvSpPr>
+          <p:cNvPr id="29" name="TextBox 28"/>
           <p:cNvSpPr txBox="1"/>
           <p:nvPr/>
         </p:nvSpPr>
         <p:spPr>
           <a:xfrm>
-            <a:off x="6720840" y="1188720"/>
-            <a:ext cx="4892040" cy="310896"/>
+            <a:off x="1389888" y="5184648"/>
+            <a:ext cx="4672583" cy="365760"/>
           </a:xfrm>
           <a:prstGeom prst="rect">
             <a:avLst/>
@@ -22536,42 +22639,19 @@
                 <a:spcPts val="0"/>
               </a:spcBef>
               <a:spcAft>
-                <a:spcPts val="0"/>
+                <a:spcPts val="100"/>
               </a:spcAft>
             </a:pPr>
             <a:r>
               <a:rPr sz="1400" b="1" i="0">
                 <a:solidFill>
-                  <a:srgbClr val="12275D"/>
+                  <a:srgbClr val="FFFFFF"/>
                 </a:solidFill>
                 <a:latin typeface="Arial"/>
               </a:rPr>
-              <a:t>Cặp A/B thật trên sc_011 — xe máy tạt đầu rồi phanh</a:t>
-            </a:r>
-          </a:p>
-        </p:txBody>
-      </p:sp>
-      <p:sp>
-        <p:nvSpPr>
-          <p:cNvPr id="28" name="TextBox 27"/>
-          <p:cNvSpPr txBox="1"/>
-          <p:nvPr/>
-        </p:nvSpPr>
-        <p:spPr>
-          <a:xfrm>
-            <a:off x="6848855" y="1572768"/>
-            <a:ext cx="1600200" cy="365760"/>
-          </a:xfrm>
-          <a:prstGeom prst="rect">
-            <a:avLst/>
-          </a:prstGeom>
-          <a:noFill/>
-        </p:spPr>
-        <p:txBody>
-          <a:bodyPr wrap="square" anchor="ctr" lIns="0" rIns="0" tIns="0" bIns="0">
-            <a:spAutoFit/>
-          </a:bodyPr>
-          <a:lstStyle/>
+              <a:t>Chưa đủ khó → dò biến thể</a:t>
+            </a:r>
+          </a:p>
           <a:p>
             <a:pPr algn="l">
               <a:lnSpc>
@@ -22585,27 +22665,27 @@
               </a:spcAft>
             </a:pPr>
             <a:r>
-              <a:rPr sz="1200" b="1" i="0">
-                <a:solidFill>
-                  <a:srgbClr val="12275D"/>
+              <a:rPr sz="1100" b="0" i="0">
+                <a:solidFill>
+                  <a:srgbClr val="FFFFFF"/>
                 </a:solidFill>
                 <a:latin typeface="Arial"/>
               </a:rPr>
-              <a:t/>
-            </a:r>
-          </a:p>
-        </p:txBody>
-      </p:sp>
-      <p:sp>
-        <p:nvSpPr>
-          <p:cNvPr id="29" name="TextBox 28"/>
+              <a:t>dịch trigger quanh mốc vật lý, quay lại bước 3</a:t>
+            </a:r>
+          </a:p>
+        </p:txBody>
+      </p:sp>
+      <p:sp>
+        <p:nvSpPr>
+          <p:cNvPr id="30" name="TextBox 29"/>
           <p:cNvSpPr txBox="1"/>
           <p:nvPr/>
         </p:nvSpPr>
         <p:spPr>
           <a:xfrm>
-            <a:off x="8503919" y="1572768"/>
-            <a:ext cx="1463040" cy="365760"/>
+            <a:off x="6720840" y="1188720"/>
+            <a:ext cx="4892040" cy="310896"/>
           </a:xfrm>
           <a:prstGeom prst="rect">
             <a:avLst/>
@@ -22613,7 +22693,7 @@
           <a:noFill/>
         </p:spPr>
         <p:txBody>
-          <a:bodyPr wrap="square" anchor="ctr" lIns="0" rIns="0" tIns="0" bIns="0">
+          <a:bodyPr wrap="square" anchor="t" lIns="0" rIns="0" tIns="0" bIns="0">
             <a:spAutoFit/>
           </a:bodyPr>
           <a:lstStyle/>
@@ -22630,27 +22710,27 @@
               </a:spcAft>
             </a:pPr>
             <a:r>
-              <a:rPr sz="1200" b="1" i="0">
+              <a:rPr sz="1400" b="1" i="0">
                 <a:solidFill>
                   <a:srgbClr val="12275D"/>
                 </a:solidFill>
                 <a:latin typeface="Arial"/>
               </a:rPr>
-              <a:t>Baseline</a:t>
-            </a:r>
-          </a:p>
-        </p:txBody>
-      </p:sp>
-      <p:sp>
-        <p:nvSpPr>
-          <p:cNvPr id="30" name="TextBox 29"/>
+              <a:t>Cặp A/B thật trên sc_011 — xe máy tạt đầu rồi phanh</a:t>
+            </a:r>
+          </a:p>
+        </p:txBody>
+      </p:sp>
+      <p:sp>
+        <p:nvSpPr>
+          <p:cNvPr id="31" name="TextBox 30"/>
           <p:cNvSpPr txBox="1"/>
           <p:nvPr/>
         </p:nvSpPr>
         <p:spPr>
           <a:xfrm>
-            <a:off x="10058400" y="1572768"/>
-            <a:ext cx="1463040" cy="365760"/>
+            <a:off x="6848855" y="1572768"/>
+            <a:ext cx="1600200" cy="365760"/>
           </a:xfrm>
           <a:prstGeom prst="rect">
             <a:avLst/>
@@ -22681,6 +22761,96 @@
                 </a:solidFill>
                 <a:latin typeface="Arial"/>
               </a:rPr>
+              <a:t/>
+            </a:r>
+          </a:p>
+        </p:txBody>
+      </p:sp>
+      <p:sp>
+        <p:nvSpPr>
+          <p:cNvPr id="32" name="TextBox 31"/>
+          <p:cNvSpPr txBox="1"/>
+          <p:nvPr/>
+        </p:nvSpPr>
+        <p:spPr>
+          <a:xfrm>
+            <a:off x="8503919" y="1572768"/>
+            <a:ext cx="1463040" cy="365760"/>
+          </a:xfrm>
+          <a:prstGeom prst="rect">
+            <a:avLst/>
+          </a:prstGeom>
+          <a:noFill/>
+        </p:spPr>
+        <p:txBody>
+          <a:bodyPr wrap="square" anchor="ctr" lIns="0" rIns="0" tIns="0" bIns="0">
+            <a:spAutoFit/>
+          </a:bodyPr>
+          <a:lstStyle/>
+          <a:p>
+            <a:pPr algn="l">
+              <a:lnSpc>
+                <a:spcPct val="100000"/>
+              </a:lnSpc>
+              <a:spcBef>
+                <a:spcPts val="0"/>
+              </a:spcBef>
+              <a:spcAft>
+                <a:spcPts val="0"/>
+              </a:spcAft>
+            </a:pPr>
+            <a:r>
+              <a:rPr sz="1200" b="1" i="0">
+                <a:solidFill>
+                  <a:srgbClr val="12275D"/>
+                </a:solidFill>
+                <a:latin typeface="Arial"/>
+              </a:rPr>
+              <a:t>Baseline</a:t>
+            </a:r>
+          </a:p>
+        </p:txBody>
+      </p:sp>
+      <p:sp>
+        <p:nvSpPr>
+          <p:cNvPr id="33" name="TextBox 32"/>
+          <p:cNvSpPr txBox="1"/>
+          <p:nvPr/>
+        </p:nvSpPr>
+        <p:spPr>
+          <a:xfrm>
+            <a:off x="10058400" y="1572768"/>
+            <a:ext cx="1463040" cy="365760"/>
+          </a:xfrm>
+          <a:prstGeom prst="rect">
+            <a:avLst/>
+          </a:prstGeom>
+          <a:noFill/>
+        </p:spPr>
+        <p:txBody>
+          <a:bodyPr wrap="square" anchor="ctr" lIns="0" rIns="0" tIns="0" bIns="0">
+            <a:spAutoFit/>
+          </a:bodyPr>
+          <a:lstStyle/>
+          <a:p>
+            <a:pPr algn="l">
+              <a:lnSpc>
+                <a:spcPct val="100000"/>
+              </a:lnSpc>
+              <a:spcBef>
+                <a:spcPts val="0"/>
+              </a:spcBef>
+              <a:spcAft>
+                <a:spcPts val="0"/>
+              </a:spcAft>
+            </a:pPr>
+            <a:r>
+              <a:rPr sz="1200" b="1" i="0">
+                <a:solidFill>
+                  <a:srgbClr val="12275D"/>
+                </a:solidFill>
+                <a:latin typeface="Arial"/>
+              </a:rPr>
               <a:t>BehaviorAgent</a:t>
             </a:r>
           </a:p>
@@ -22688,7 +22858,7 @@
       </p:sp>
       <p:sp>
         <p:nvSpPr>
-          <p:cNvPr id="31" name="Rectangle 30"/>
+          <p:cNvPr id="34" name="Rectangle 33"/>
           <p:cNvSpPr/>
           <p:nvPr/>
         </p:nvSpPr>
@@ -22732,7 +22902,7 @@
       </p:sp>
       <p:sp>
         <p:nvSpPr>
-          <p:cNvPr id="32" name="TextBox 31"/>
+          <p:cNvPr id="35" name="TextBox 34"/>
           <p:cNvSpPr txBox="1"/>
           <p:nvPr/>
         </p:nvSpPr>
@@ -22777,7 +22947,7 @@
       </p:sp>
       <p:sp>
         <p:nvSpPr>
-          <p:cNvPr id="33" name="TextBox 32"/>
+          <p:cNvPr id="36" name="TextBox 35"/>
           <p:cNvSpPr txBox="1"/>
           <p:nvPr/>
         </p:nvSpPr>
@@ -22822,7 +22992,7 @@
       </p:sp>
       <p:sp>
         <p:nvSpPr>
-          <p:cNvPr id="34" name="TextBox 33"/>
+          <p:cNvPr id="37" name="TextBox 36"/>
           <p:cNvSpPr txBox="1"/>
           <p:nvPr/>
         </p:nvSpPr>
@@ -22867,7 +23037,7 @@
       </p:sp>
       <p:sp>
         <p:nvSpPr>
-          <p:cNvPr id="35" name="Rectangle 34"/>
+          <p:cNvPr id="38" name="Rectangle 37"/>
           <p:cNvSpPr/>
           <p:nvPr/>
         </p:nvSpPr>
@@ -22911,7 +23081,7 @@
       </p:sp>
       <p:sp>
         <p:nvSpPr>
-          <p:cNvPr id="36" name="TextBox 35"/>
+          <p:cNvPr id="39" name="TextBox 38"/>
           <p:cNvSpPr txBox="1"/>
           <p:nvPr/>
         </p:nvSpPr>
@@ -22956,7 +23126,7 @@
       </p:sp>
       <p:sp>
         <p:nvSpPr>
-          <p:cNvPr id="37" name="TextBox 36"/>
+          <p:cNvPr id="40" name="TextBox 39"/>
           <p:cNvSpPr txBox="1"/>
           <p:nvPr/>
         </p:nvSpPr>
@@ -23001,7 +23171,7 @@
       </p:sp>
       <p:sp>
         <p:nvSpPr>
-          <p:cNvPr id="38" name="TextBox 37"/>
+          <p:cNvPr id="41" name="TextBox 40"/>
           <p:cNvSpPr txBox="1"/>
           <p:nvPr/>
         </p:nvSpPr>
@@ -23046,7 +23216,7 @@
       </p:sp>
       <p:sp>
         <p:nvSpPr>
-          <p:cNvPr id="39" name="Rectangle 38"/>
+          <p:cNvPr id="42" name="Rectangle 41"/>
           <p:cNvSpPr/>
           <p:nvPr/>
         </p:nvSpPr>
@@ -23090,7 +23260,7 @@
       </p:sp>
       <p:sp>
         <p:nvSpPr>
-          <p:cNvPr id="40" name="TextBox 39"/>
+          <p:cNvPr id="43" name="TextBox 42"/>
           <p:cNvSpPr txBox="1"/>
           <p:nvPr/>
         </p:nvSpPr>
@@ -23135,7 +23305,7 @@
       </p:sp>
       <p:sp>
         <p:nvSpPr>
-          <p:cNvPr id="41" name="TextBox 40"/>
+          <p:cNvPr id="44" name="TextBox 43"/>
           <p:cNvSpPr txBox="1"/>
           <p:nvPr/>
         </p:nvSpPr>
@@ -23180,7 +23350,7 @@
       </p:sp>
       <p:sp>
         <p:nvSpPr>
-          <p:cNvPr id="42" name="TextBox 41"/>
+          <p:cNvPr id="45" name="TextBox 44"/>
           <p:cNvSpPr txBox="1"/>
           <p:nvPr/>
         </p:nvSpPr>
@@ -23225,7 +23395,7 @@
       </p:sp>
       <p:sp>
         <p:nvSpPr>
-          <p:cNvPr id="43" name="Rectangle 42"/>
+          <p:cNvPr id="46" name="Rectangle 45"/>
           <p:cNvSpPr/>
           <p:nvPr/>
         </p:nvSpPr>
@@ -23271,7 +23441,7 @@
       </p:sp>
       <p:sp>
         <p:nvSpPr>
-          <p:cNvPr id="44" name="TextBox 43"/>
+          <p:cNvPr id="47" name="TextBox 46"/>
           <p:cNvSpPr txBox="1"/>
           <p:nvPr/>
         </p:nvSpPr>
@@ -23338,7 +23508,7 @@
       </p:sp>
       <p:sp>
         <p:nvSpPr>
-          <p:cNvPr id="45" name="TextBox 44"/>
+          <p:cNvPr id="48" name="TextBox 47"/>
           <p:cNvSpPr txBox="1"/>
           <p:nvPr/>
         </p:nvSpPr>

</xml_diff>

<commit_message>
docs: đính chính §9.6 và rút slide 8 còn một việc (#102)
</commit_message>
<xml_diff>
--- a/presentation/pitch_deck.pptx
+++ b/presentation/pitch_deck.pptx
@@ -1372,82 +1372,137 @@
           <a:lstStyle/>
           <a:p>
             <a:r>
-              <a:t>Bốn việc tiếp theo, xếp theo giá trị.</a:t>
+              <a:t>Một việc, và nó là chỗ có giá trị thương mại: cắm controller của doanh nghiệp</a:t>
+            </a:r>
+          </a:p>
+          <a:p>
+            <a:r>
+              <a:t>vào đúng chỗ BehaviorAgent đang đứng. Kiến trúc đã chừa sẵn khe đó — thêm một</a:t>
+            </a:r>
+          </a:p>
+          <a:p>
+            <a:r>
+              <a:t>adapter ở worker, backend không phải sửa gì.</a:t>
             </a:r>
           </a:p>
           <a:p/>
           <a:p>
             <a:r>
-              <a:t>Việc lớn nhất, và cũng là chỗ có giá trị thương mại: cắm controller của doanh</a:t>
-            </a:r>
-          </a:p>
-          <a:p>
-            <a:r>
-              <a:t>nghiệp vào đúng chỗ BehaviorAgent đang đứng. Kiến trúc đã chừa sẵn khe đó — thêm</a:t>
-            </a:r>
-          </a:p>
-          <a:p>
-            <a:r>
-              <a:t>một adapter ở worker, backend không phải sửa gì. Lúc đó câu hỏi đổi thành "kịch</a:t>
-            </a:r>
-          </a:p>
-          <a:p>
-            <a:r>
-              <a:t>bản nào làm controller CỦA BẠN thất bại", và đó mới là câu doanh nghiệp trả tiền</a:t>
-            </a:r>
-          </a:p>
-          <a:p>
-            <a:r>
-              <a:t>để trả lời.</a:t>
+              <a:t>Lúc đó câu hỏi đổi thành "kịch bản nào làm controller CỦA BẠN thất bại", và đó</a:t>
+            </a:r>
+          </a:p>
+          <a:p>
+            <a:r>
+              <a:t>mới là câu doanh nghiệp trả tiền để trả lời.</a:t>
             </a:r>
           </a:p>
           <a:p/>
           <a:p>
             <a:r>
-              <a:t>Việc thứ hai dễ nhất: chạy CARLA cho các ô đã có kịch bản mà chưa có lượt chạy.</a:t>
-            </a:r>
-          </a:p>
-          <a:p>
-            <a:r>
-              <a:t>Phần sinh đã xong, phần còn lại là thời gian máy.</a:t>
+              <a:t>Repo, live URL, kiến trúc và báo cáo đánh giá đầy đủ ở slide này. Em xin hết,</a:t>
+            </a:r>
+          </a:p>
+          <a:p>
+            <a:r>
+              <a:t>mời mọi người hỏi.</a:t>
             </a:r>
           </a:p>
           <a:p/>
           <a:p>
             <a:r>
-              <a:t>Việc thứ ba là giới hạn em đo được. Bộ dò biến thể đi một hướng. Có một ca bản</a:t>
-            </a:r>
-          </a:p>
-          <a:p>
-            <a:r>
-              <a:t>gốc đã ở 0,77 mét mà phép dò kéo lên 1,18 — vì cái mốc nó nhắm không phải lúc</a:t>
-            </a:r>
-          </a:p>
-          <a:p>
-            <a:r>
-              <a:t>nào cũng là điểm tới hạn nhất. Hệ thống báo "không cải thiện" cho ca đó thay vì</a:t>
-            </a:r>
-          </a:p>
-          <a:p>
-            <a:r>
-              <a:t>giấu. Lời giải là dò hai chiều.</a:t>
+              <a:t>--- Nếu bị hỏi "còn gì nữa chưa làm" thì ba việc sau, theo thứ tự:</a:t>
             </a:r>
           </a:p>
           <a:p/>
           <a:p>
             <a:r>
-              <a:t>Việc thứ tư là kỹ thuật thuần: siết token và role ở backend.</a:t>
+              <a:t>1. Bộ dò biến thể hiện đi một hướng. Có ca bản gốc đã ở 0,77 mét mà phép dò kéo</a:t>
+            </a:r>
+          </a:p>
+          <a:p>
+            <a:r>
+              <a:t>   lên 1,18 — cái mốc nó nhắm không phải lúc nào cũng là điểm tới hạn nhất. Hệ</a:t>
+            </a:r>
+          </a:p>
+          <a:p>
+            <a:r>
+              <a:t>   thống báo "không cải thiện" cho ca đó thay vì giấu. Lời giải là dò hai chiều.</a:t>
             </a:r>
           </a:p>
           <a:p/>
           <a:p>
             <a:r>
-              <a:t>Repo, live URL, kiến trúc và báo cáo đánh giá đầy đủ ở slide này. Em xin hết,</a:t>
-            </a:r>
-          </a:p>
-          <a:p>
-            <a:r>
-              <a:t>mời mọi người hỏi.</a:t>
+              <a:t>2. Tiêu chí xếp hạng biến thể nên tính thêm độ bền, không chỉ khe hở nhỏ nhất.</a:t>
+            </a:r>
+          </a:p>
+          <a:p>
+            <a:r>
+              <a:t>   Đo được là ở sát điểm tới hạn một khác biệt cỡ một phần mười giây lật hẳn nhãn</a:t>
+            </a:r>
+          </a:p>
+          <a:p>
+            <a:r>
+              <a:t>   va chạm — nên ca 0,1 mét không tái lập chắc chắn, ca va chạm dứt khoát đáng</a:t>
+            </a:r>
+          </a:p>
+          <a:p>
+            <a:r>
+              <a:t>   giữ hơn.</a:t>
+            </a:r>
+          </a:p>
+          <a:p/>
+          <a:p>
+            <a:r>
+              <a:t>3. Siết token và role ở backend, hiện mới phân vai trên frontend.</a:t>
+            </a:r>
+          </a:p>
+          <a:p/>
+          <a:p>
+            <a:r>
+              <a:t>--- Nếu bị hỏi "sao không tải kịch bản có sẵn về dùng":</a:t>
+            </a:r>
+          </a:p>
+          <a:p/>
+          <a:p>
+            <a:r>
+              <a:t>ScenarioRunner có sẵn 35 lớp kịch bản, gồm đúng cut_in và hard_break. Nhưng kịch</a:t>
+            </a:r>
+          </a:p>
+          <a:p>
+            <a:r>
+              <a:t>bản có sẵn cho bạn LOẠI tình huống, không cho bạn biết ở tốc độ nào thì xe của</a:t>
+            </a:r>
+          </a:p>
+          <a:p>
+            <a:r>
+              <a:t>bạn đâm.</a:t>
+            </a:r>
+          </a:p>
+          <a:p/>
+          <a:p>
+            <a:r>
+              <a:t>Ví dụ thật: một ô vượt đèn đỏ, xe tải 36 km/h — đúng nhãn, đúng ODD, chạy trọn</a:t>
+            </a:r>
+          </a:p>
+          <a:p>
+            <a:r>
+              <a:t>vẹn, khe hở gần 7 mét, vô dụng. Cùng kịch bản đó ở 22,2 km/h thì va chạm. Mười</a:t>
+            </a:r>
+          </a:p>
+          <a:p>
+            <a:r>
+              <a:t>bốn trong hai mươi kịch bản vượt đèn đỏ sinh ra hôm nay chạy xong mà vô hại.</a:t>
+            </a:r>
+          </a:p>
+          <a:p/>
+          <a:p>
+            <a:r>
+              <a:t>Nguy hiểm không phải thuộc tính của loại maneuver. Nó là thuộc tính của bộ tham</a:t>
+            </a:r>
+          </a:p>
+          <a:p>
+            <a:r>
+              <a:t>số cụ thể, đối với một mô hình lái cụ thể. Chỗ đó em đo được và tự dò tới.</a:t>
             </a:r>
           </a:p>
         </p:txBody>
@@ -11782,8 +11837,8 @@
         </p:nvSpPr>
         <p:spPr>
           <a:xfrm>
-            <a:off x="1188720" y="1188720"/>
-            <a:ext cx="10424159" cy="786384"/>
+            <a:off x="1188720" y="1463040"/>
+            <a:ext cx="10424159" cy="2148840"/>
           </a:xfrm>
           <a:prstGeom prst="rect">
             <a:avLst/>
@@ -11828,8 +11883,8 @@
         </p:nvSpPr>
         <p:spPr>
           <a:xfrm>
-            <a:off x="1463040" y="1316736"/>
-            <a:ext cx="9875519" cy="566928"/>
+            <a:off x="1600200" y="1755648"/>
+            <a:ext cx="9601199" cy="1645920"/>
           </a:xfrm>
           <a:prstGeom prst="rect">
             <a:avLst/>
@@ -11850,11 +11905,11 @@
                 <a:spcPts val="0"/>
               </a:spcBef>
               <a:spcAft>
-                <a:spcPts val="300"/>
+                <a:spcPts val="1600"/>
               </a:spcAft>
             </a:pPr>
             <a:r>
-              <a:rPr sz="1600" b="1" i="0">
+              <a:rPr sz="2600" b="1" i="0">
                 <a:solidFill>
                   <a:srgbClr val="12275D"/>
                 </a:solidFill>
@@ -11866,23 +11921,45 @@
           <a:p>
             <a:pPr algn="l">
               <a:lnSpc>
-                <a:spcPct val="110000"/>
+                <a:spcPct val="120000"/>
               </a:lnSpc>
               <a:spcBef>
                 <a:spcPts val="0"/>
               </a:spcBef>
               <a:spcAft>
-                <a:spcPts val="0"/>
+                <a:spcPts val="1200"/>
               </a:spcAft>
             </a:pPr>
             <a:r>
-              <a:rPr sz="1300" b="0" i="0">
+              <a:rPr sz="1700" b="0" i="0">
                 <a:solidFill>
                   <a:srgbClr val="5A6472"/>
                 </a:solidFill>
                 <a:latin typeface="Arial"/>
               </a:rPr>
-              <a:t>Thêm một adapter ở worker là xong — backend không phải đụng tới. Câu hỏi đổi thành: kịch bản nào làm controller CỦA BẠN thất bại.</a:t>
+              <a:t>Thêm một adapter ở worker là xong — backend không phải đụng tới.</a:t>
+            </a:r>
+          </a:p>
+          <a:p>
+            <a:pPr algn="l">
+              <a:lnSpc>
+                <a:spcPct val="120000"/>
+              </a:lnSpc>
+              <a:spcBef>
+                <a:spcPts val="0"/>
+              </a:spcBef>
+              <a:spcAft>
+                <a:spcPts val="0"/>
+              </a:spcAft>
+            </a:pPr>
+            <a:r>
+              <a:rPr sz="1800" b="1" i="0">
+                <a:solidFill>
+                  <a:srgbClr val="E06C1F"/>
+                </a:solidFill>
+                <a:latin typeface="Arial"/>
+              </a:rPr>
+              <a:t>Câu hỏi đổi thành: kịch bản nào làm controller CỦA BẠN thất bại.</a:t>
             </a:r>
           </a:p>
         </p:txBody>
@@ -11895,347 +11972,8 @@
         </p:nvSpPr>
         <p:spPr>
           <a:xfrm>
-            <a:off x="1188720" y="2121408"/>
-            <a:ext cx="10424159" cy="786384"/>
-          </a:xfrm>
-          <a:prstGeom prst="rect">
-            <a:avLst/>
-          </a:prstGeom>
-          <a:solidFill>
-            <a:srgbClr val="FFFFFF"/>
-          </a:solidFill>
-          <a:ln w="9525">
-            <a:solidFill>
-              <a:srgbClr val="D5DAE4"/>
-            </a:solidFill>
-          </a:ln>
-          <a:effectLst/>
-        </p:spPr>
-        <p:style>
-          <a:lnRef idx="1">
-            <a:schemeClr val="accent1"/>
-          </a:lnRef>
-          <a:fillRef idx="3">
-            <a:schemeClr val="accent1"/>
-          </a:fillRef>
-          <a:effectRef idx="2">
-            <a:schemeClr val="accent1"/>
-          </a:effectRef>
-          <a:fontRef idx="minor">
-            <a:schemeClr val="lt1"/>
-          </a:fontRef>
-        </p:style>
-        <p:txBody>
-          <a:bodyPr rtlCol="0" anchor="ctr" wrap="square"/>
-          <a:lstStyle/>
-          <a:p>
-            <a:pPr algn="ctr"/>
-          </a:p>
-        </p:txBody>
-      </p:sp>
-      <p:sp>
-        <p:nvSpPr>
-          <p:cNvPr id="12" name="TextBox 11"/>
-          <p:cNvSpPr txBox="1"/>
-          <p:nvPr/>
-        </p:nvSpPr>
-        <p:spPr>
-          <a:xfrm>
-            <a:off x="1463040" y="2249424"/>
-            <a:ext cx="9875519" cy="566928"/>
-          </a:xfrm>
-          <a:prstGeom prst="rect">
-            <a:avLst/>
-          </a:prstGeom>
-          <a:noFill/>
-        </p:spPr>
-        <p:txBody>
-          <a:bodyPr wrap="square" anchor="t" lIns="0" rIns="0" tIns="0" bIns="0">
-            <a:spAutoFit/>
-          </a:bodyPr>
-          <a:lstStyle/>
-          <a:p>
-            <a:pPr algn="l">
-              <a:lnSpc>
-                <a:spcPct val="100000"/>
-              </a:lnSpc>
-              <a:spcBef>
-                <a:spcPts val="0"/>
-              </a:spcBef>
-              <a:spcAft>
-                <a:spcPts val="300"/>
-              </a:spcAft>
-            </a:pPr>
-            <a:r>
-              <a:rPr sz="1600" b="1" i="0">
-                <a:solidFill>
-                  <a:srgbClr val="12275D"/>
-                </a:solidFill>
-                <a:latin typeface="Arial"/>
-              </a:rPr>
-              <a:t>Chạy CARLA cho các ô còn lại</a:t>
-            </a:r>
-          </a:p>
-          <a:p>
-            <a:pPr algn="l">
-              <a:lnSpc>
-                <a:spcPct val="110000"/>
-              </a:lnSpc>
-              <a:spcBef>
-                <a:spcPts val="0"/>
-              </a:spcBef>
-              <a:spcAft>
-                <a:spcPts val="0"/>
-              </a:spcAft>
-            </a:pPr>
-            <a:r>
-              <a:rPr sz="1300" b="0" i="0">
-                <a:solidFill>
-                  <a:srgbClr val="5A6472"/>
-                </a:solidFill>
-                <a:latin typeface="Arial"/>
-              </a:rPr>
-              <a:t>Ô đã kín 72/72, lượt chạy thật thì chưa. Phần sinh đã xong, phần còn lại là thời gian máy.</a:t>
-            </a:r>
-          </a:p>
-        </p:txBody>
-      </p:sp>
-      <p:sp>
-        <p:nvSpPr>
-          <p:cNvPr id="13" name="Rectangle 12"/>
-          <p:cNvSpPr/>
-          <p:nvPr/>
-        </p:nvSpPr>
-        <p:spPr>
-          <a:xfrm>
-            <a:off x="1188720" y="3054096"/>
-            <a:ext cx="10424159" cy="786384"/>
-          </a:xfrm>
-          <a:prstGeom prst="rect">
-            <a:avLst/>
-          </a:prstGeom>
-          <a:solidFill>
-            <a:srgbClr val="F2F4F8"/>
-          </a:solidFill>
-          <a:ln w="9525">
-            <a:solidFill>
-              <a:srgbClr val="D5DAE4"/>
-            </a:solidFill>
-          </a:ln>
-          <a:effectLst/>
-        </p:spPr>
-        <p:style>
-          <a:lnRef idx="1">
-            <a:schemeClr val="accent1"/>
-          </a:lnRef>
-          <a:fillRef idx="3">
-            <a:schemeClr val="accent1"/>
-          </a:fillRef>
-          <a:effectRef idx="2">
-            <a:schemeClr val="accent1"/>
-          </a:effectRef>
-          <a:fontRef idx="minor">
-            <a:schemeClr val="lt1"/>
-          </a:fontRef>
-        </p:style>
-        <p:txBody>
-          <a:bodyPr rtlCol="0" anchor="ctr" wrap="square"/>
-          <a:lstStyle/>
-          <a:p>
-            <a:pPr algn="ctr"/>
-          </a:p>
-        </p:txBody>
-      </p:sp>
-      <p:sp>
-        <p:nvSpPr>
-          <p:cNvPr id="14" name="TextBox 13"/>
-          <p:cNvSpPr txBox="1"/>
-          <p:nvPr/>
-        </p:nvSpPr>
-        <p:spPr>
-          <a:xfrm>
-            <a:off x="1463040" y="3182112"/>
-            <a:ext cx="9875519" cy="566928"/>
-          </a:xfrm>
-          <a:prstGeom prst="rect">
-            <a:avLst/>
-          </a:prstGeom>
-          <a:noFill/>
-        </p:spPr>
-        <p:txBody>
-          <a:bodyPr wrap="square" anchor="t" lIns="0" rIns="0" tIns="0" bIns="0">
-            <a:spAutoFit/>
-          </a:bodyPr>
-          <a:lstStyle/>
-          <a:p>
-            <a:pPr algn="l">
-              <a:lnSpc>
-                <a:spcPct val="100000"/>
-              </a:lnSpc>
-              <a:spcBef>
-                <a:spcPts val="0"/>
-              </a:spcBef>
-              <a:spcAft>
-                <a:spcPts val="300"/>
-              </a:spcAft>
-            </a:pPr>
-            <a:r>
-              <a:rPr sz="1600" b="1" i="0">
-                <a:solidFill>
-                  <a:srgbClr val="12275D"/>
-                </a:solidFill>
-                <a:latin typeface="Arial"/>
-              </a:rPr>
-              <a:t>Dò biến thể hai chiều</a:t>
-            </a:r>
-          </a:p>
-          <a:p>
-            <a:pPr algn="l">
-              <a:lnSpc>
-                <a:spcPct val="110000"/>
-              </a:lnSpc>
-              <a:spcBef>
-                <a:spcPts val="0"/>
-              </a:spcBef>
-              <a:spcAft>
-                <a:spcPts val="0"/>
-              </a:spcAft>
-            </a:pPr>
-            <a:r>
-              <a:rPr sz="1300" b="0" i="0">
-                <a:solidFill>
-                  <a:srgbClr val="5A6472"/>
-                </a:solidFill>
-                <a:latin typeface="Arial"/>
-              </a:rPr>
-              <a:t>Bộ dò hiện đi một hướng. Có ca bước đầu tệ hơn bản gốc — lúc đó phải đổi chiều thay vì đi tiếp.</a:t>
-            </a:r>
-          </a:p>
-        </p:txBody>
-      </p:sp>
-      <p:sp>
-        <p:nvSpPr>
-          <p:cNvPr id="15" name="Rectangle 14"/>
-          <p:cNvSpPr/>
-          <p:nvPr/>
-        </p:nvSpPr>
-        <p:spPr>
-          <a:xfrm>
-            <a:off x="1188720" y="3986784"/>
-            <a:ext cx="10424159" cy="786384"/>
-          </a:xfrm>
-          <a:prstGeom prst="rect">
-            <a:avLst/>
-          </a:prstGeom>
-          <a:solidFill>
-            <a:srgbClr val="FFFFFF"/>
-          </a:solidFill>
-          <a:ln w="9525">
-            <a:solidFill>
-              <a:srgbClr val="D5DAE4"/>
-            </a:solidFill>
-          </a:ln>
-          <a:effectLst/>
-        </p:spPr>
-        <p:style>
-          <a:lnRef idx="1">
-            <a:schemeClr val="accent1"/>
-          </a:lnRef>
-          <a:fillRef idx="3">
-            <a:schemeClr val="accent1"/>
-          </a:fillRef>
-          <a:effectRef idx="2">
-            <a:schemeClr val="accent1"/>
-          </a:effectRef>
-          <a:fontRef idx="minor">
-            <a:schemeClr val="lt1"/>
-          </a:fontRef>
-        </p:style>
-        <p:txBody>
-          <a:bodyPr rtlCol="0" anchor="ctr" wrap="square"/>
-          <a:lstStyle/>
-          <a:p>
-            <a:pPr algn="ctr"/>
-          </a:p>
-        </p:txBody>
-      </p:sp>
-      <p:sp>
-        <p:nvSpPr>
-          <p:cNvPr id="16" name="TextBox 15"/>
-          <p:cNvSpPr txBox="1"/>
-          <p:nvPr/>
-        </p:nvSpPr>
-        <p:spPr>
-          <a:xfrm>
-            <a:off x="1463040" y="4114800"/>
-            <a:ext cx="9875519" cy="566928"/>
-          </a:xfrm>
-          <a:prstGeom prst="rect">
-            <a:avLst/>
-          </a:prstGeom>
-          <a:noFill/>
-        </p:spPr>
-        <p:txBody>
-          <a:bodyPr wrap="square" anchor="t" lIns="0" rIns="0" tIns="0" bIns="0">
-            <a:spAutoFit/>
-          </a:bodyPr>
-          <a:lstStyle/>
-          <a:p>
-            <a:pPr algn="l">
-              <a:lnSpc>
-                <a:spcPct val="100000"/>
-              </a:lnSpc>
-              <a:spcBef>
-                <a:spcPts val="0"/>
-              </a:spcBef>
-              <a:spcAft>
-                <a:spcPts val="300"/>
-              </a:spcAft>
-            </a:pPr>
-            <a:r>
-              <a:rPr sz="1600" b="1" i="0">
-                <a:solidFill>
-                  <a:srgbClr val="12275D"/>
-                </a:solidFill>
-                <a:latin typeface="Arial"/>
-              </a:rPr>
-              <a:t>Siết phân quyền ở backend</a:t>
-            </a:r>
-          </a:p>
-          <a:p>
-            <a:pPr algn="l">
-              <a:lnSpc>
-                <a:spcPct val="110000"/>
-              </a:lnSpc>
-              <a:spcBef>
-                <a:spcPts val="0"/>
-              </a:spcBef>
-              <a:spcAft>
-                <a:spcPts val="0"/>
-              </a:spcAft>
-            </a:pPr>
-            <a:r>
-              <a:rPr sz="1300" b="0" i="0">
-                <a:solidFill>
-                  <a:srgbClr val="5A6472"/>
-                </a:solidFill>
-                <a:latin typeface="Arial"/>
-              </a:rPr>
-              <a:t>Enforce token/role cho review và WORKER_TOKEN, không chỉ phân vai trên frontend.</a:t>
-            </a:r>
-          </a:p>
-        </p:txBody>
-      </p:sp>
-      <p:sp>
-        <p:nvSpPr>
-          <p:cNvPr id="17" name="Rectangle 16"/>
-          <p:cNvSpPr/>
-          <p:nvPr/>
-        </p:nvSpPr>
-        <p:spPr>
-          <a:xfrm>
-            <a:off x="1188720" y="4846320"/>
-            <a:ext cx="10424159" cy="1234440"/>
+            <a:off x="1188720" y="4160520"/>
+            <a:ext cx="10424159" cy="1554480"/>
           </a:xfrm>
           <a:prstGeom prst="rect">
             <a:avLst/>
@@ -12272,14 +12010,14 @@
       </p:sp>
       <p:sp>
         <p:nvSpPr>
-          <p:cNvPr id="18" name="TextBox 17"/>
+          <p:cNvPr id="12" name="TextBox 11"/>
           <p:cNvSpPr txBox="1"/>
           <p:nvPr/>
         </p:nvSpPr>
         <p:spPr>
           <a:xfrm>
-            <a:off x="1508760" y="5047488"/>
-            <a:ext cx="9784080" cy="914400"/>
+            <a:off x="1508760" y="4462272"/>
+            <a:ext cx="9784080" cy="1051560"/>
           </a:xfrm>
           <a:prstGeom prst="rect">
             <a:avLst/>
@@ -12300,11 +12038,11 @@
                 <a:spcPts val="0"/>
               </a:spcBef>
               <a:spcAft>
-                <a:spcPts val="600"/>
+                <a:spcPts val="1000"/>
               </a:spcAft>
             </a:pPr>
             <a:r>
-              <a:rPr sz="1500" b="1" i="0">
+              <a:rPr sz="1800" b="1" i="0">
                 <a:solidFill>
                   <a:srgbClr val="FFFFFF"/>
                 </a:solidFill>
@@ -12322,17 +12060,39 @@
                 <a:spcPts val="0"/>
               </a:spcBef>
               <a:spcAft>
-                <a:spcPts val="0"/>
+                <a:spcPts val="500"/>
               </a:spcAft>
             </a:pPr>
             <a:r>
-              <a:rPr sz="1300" b="0" i="0">
+              <a:rPr sz="1500" b="0" i="0">
                 <a:solidFill>
                   <a:srgbClr val="C7D2E8"/>
                 </a:solidFill>
                 <a:latin typeface="Arial"/>
               </a:rPr>
-              <a:t>c4-app-t130.vercel.app   ·   github.com/AI20K-Build-Phase-Cohort-3/P-130   ·   ARCHITECTURE.md   ·   eval/results/report.md</a:t>
+              <a:t>c4-app-t130.vercel.app   ·   github.com/AI20K-Build-Phase-Cohort-3/P-130</a:t>
+            </a:r>
+          </a:p>
+          <a:p>
+            <a:pPr algn="l">
+              <a:lnSpc>
+                <a:spcPct val="100000"/>
+              </a:lnSpc>
+              <a:spcBef>
+                <a:spcPts val="0"/>
+              </a:spcBef>
+              <a:spcAft>
+                <a:spcPts val="0"/>
+              </a:spcAft>
+            </a:pPr>
+            <a:r>
+              <a:rPr sz="1500" b="0" i="0">
+                <a:solidFill>
+                  <a:srgbClr val="C7D2E8"/>
+                </a:solidFill>
+                <a:latin typeface="Arial"/>
+              </a:rPr>
+              <a:t>ARCHITECTURE.md   ·   eval/results/report.md</a:t>
             </a:r>
           </a:p>
         </p:txBody>

</xml_diff>

<commit_message>
docs: slide 7 theo số sau khi chạy CARLA toàn bộ ô ODD (#103)
</commit_message>
<xml_diff>
--- a/presentation/pitch_deck.pptx
+++ b/presentation/pitch_deck.pptx
@@ -1244,7 +1244,7 @@
           <a:p/>
           <a:p>
             <a:r>
-              <a:t>L2 một trăm phần trăm. L3 chín mươi bảy. L4 bảy mươi sáu.</a:t>
+              <a:t>L2 một trăm phần trăm. L3 chín mươi tám. L4 sáu mươi bốn.</a:t>
             </a:r>
           </a:p>
           <a:p/>
@@ -1265,28 +1265,89 @@
           </a:p>
           <a:p>
             <a:r>
-              <a:t>Đó là loại hỏng tệ nhất vì nó trông như thành công. Bỏ L4 đi thì ba con số trên</a:t>
-            </a:r>
-          </a:p>
-          <a:p>
-            <a:r>
-              <a:t>kia chỉ nói được là "file không lỗi cú pháp".</a:t>
+              <a:t>Đó là loại hỏng tệ nhất vì nó trông như thành công.</a:t>
             </a:r>
           </a:p>
           <a:p/>
           <a:p>
             <a:r>
-              <a:t>Bốn ô dưới: phủ hết ODD trong phạm vi converter. Bảy mươi sáu phần trăm kịch bản</a:t>
-            </a:r>
-          </a:p>
-          <a:p>
-            <a:r>
-              <a:t>tái hiện được nguy hiểm. Hai mươi lăm va chạm thật trên CARLA. Và chi phí — hai</a:t>
-            </a:r>
-          </a:p>
-          <a:p>
-            <a:r>
-              <a:t>phần nghìn đô một kịch bản, p50 dưới ba giây.</a:t>
+              <a:t>--- Nếu bị hỏi "sao L4 chỉ sáu mươi bốn phần trăm", hoặc nếu muốn chủ động nói:</a:t>
+            </a:r>
+          </a:p>
+          <a:p/>
+          <a:p>
+            <a:r>
+              <a:t>Sáng nay con số này là bảy mươi sáu. Nó tụt vì em vừa chạy CARLA cho toàn bộ các</a:t>
+            </a:r>
+          </a:p>
+          <a:p>
+            <a:r>
+              <a:t>ô ODD chưa từng được kiểm — mẫu số từ năm mươi chín lên một trăm mười lăm.</a:t>
+            </a:r>
+          </a:p>
+          <a:p/>
+          <a:p>
+            <a:r>
+              <a:t>Bảy mươi sáu phần trăm là đo trên hai mươi sáu ô đã được chăm kỹ nhất. Sáu mươi</a:t>
+            </a:r>
+          </a:p>
+          <a:p>
+            <a:r>
+              <a:t>bốn là đo trên tất cả bảy mươi lăm ô. Con số thấp hơn nhưng nó là con số thật, và</a:t>
+            </a:r>
+          </a:p>
+          <a:p>
+            <a:r>
+              <a:t>em chọn để nó trên slide.</a:t>
+            </a:r>
+          </a:p>
+          <a:p/>
+          <a:p>
+            <a:r>
+              <a:t>Đổi lại: số va chạm thật đi từ hai mươi lăm lên sáu mươi mốt.</a:t>
+            </a:r>
+          </a:p>
+          <a:p/>
+          <a:p>
+            <a:r>
+              <a:t>Và nó nói đúng một điều về sản phẩm: phủ hết ô ODD KHÔNG đồng nghĩa tìm được nguy</a:t>
+            </a:r>
+          </a:p>
+          <a:p>
+            <a:r>
+              <a:t>hiểm. Một phần ba ô sinh ra kịch bản chạy trót lọt mà vô hại. Đó chính là lý do</a:t>
+            </a:r>
+          </a:p>
+          <a:p>
+            <a:r>
+              <a:t>phần dò biến thể ở slide trước tồn tại — nó biến ô vô hại thành ô có va chạm.</a:t>
+            </a:r>
+          </a:p>
+          <a:p/>
+          <a:p>
+            <a:r>
+              <a:t>--- Bốn ô số dưới:</a:t>
+            </a:r>
+          </a:p>
+          <a:p/>
+          <a:p>
+            <a:r>
+              <a:t>Sáu mươi mốt va chạm thật trên CARLA. Sáu mươi bốn phần trăm tái hiện được nguy</a:t>
+            </a:r>
+          </a:p>
+          <a:p>
+            <a:r>
+              <a:t>hiểm. Bảy mươi lăm trên bảy mươi lăm ô ODD đã có lượt chạy thật, không còn ô nào</a:t>
+            </a:r>
+          </a:p>
+          <a:p>
+            <a:r>
+              <a:t>chỉ có kịch bản trên giấy. Và chi phí — hai phần nghìn đô một kịch bản, p50 dưới</a:t>
+            </a:r>
+          </a:p>
+          <a:p>
+            <a:r>
+              <a:t>ba giây.</a:t>
             </a:r>
           </a:p>
           <a:p/>
@@ -10113,7 +10174,7 @@
                 </a:solidFill>
                 <a:latin typeface="Arial"/>
               </a:rPr>
-              <a:t>Snapshot 03/09/2026 qua /api/v1/metrics/quality. Cost/latency đo 24/08 trên 20 request.</a:t>
+              <a:t>Snapshot 03/09/2026 qua /api/v1/metrics/quality, sau khi chạy CARLA cho toàn bộ ô ODD. Cost/latency đo 24/08 trên 20 request.</a:t>
             </a:r>
           </a:p>
         </p:txBody>
@@ -10750,7 +10811,7 @@
         <p:spPr>
           <a:xfrm>
             <a:off x="4434840" y="2606040"/>
-            <a:ext cx="4466258" cy="274320"/>
+            <a:ext cx="4539680" cy="274320"/>
           </a:xfrm>
           <a:prstGeom prst="round2SameRect">
             <a:avLst/>
@@ -10825,7 +10886,7 @@
                 </a:solidFill>
                 <a:latin typeface="Arial"/>
               </a:rPr>
-              <a:t>96,7%  ·  59/61</a:t>
+              <a:t>98,3%  ·  116/118</a:t>
             </a:r>
           </a:p>
         </p:txBody>
@@ -10928,7 +10989,7 @@
         <p:spPr>
           <a:xfrm>
             <a:off x="4434840" y="3264408"/>
-            <a:ext cx="3521935" cy="274320"/>
+            <a:ext cx="2971502" cy="274320"/>
           </a:xfrm>
           <a:prstGeom prst="round2SameRect">
             <a:avLst/>
@@ -11003,7 +11064,7 @@
                 </a:solidFill>
                 <a:latin typeface="Arial"/>
               </a:rPr>
-              <a:t>76,3%  ·  45/59</a:t>
+              <a:t>64,3%  ·  74/115</a:t>
             </a:r>
           </a:p>
         </p:txBody>
@@ -11090,11 +11151,11 @@
             <a:r>
               <a:rPr sz="3200" b="1" i="0">
                 <a:solidFill>
-                  <a:srgbClr val="2F62B8"/>
+                  <a:srgbClr val="00A651"/>
                 </a:solidFill>
                 <a:latin typeface="Arial"/>
               </a:rPr>
-              <a:t>100%</a:t>
+              <a:t>61</a:t>
             </a:r>
           </a:p>
           <a:p>
@@ -11116,8 +11177,8 @@
                 </a:solidFill>
                 <a:latin typeface="Arial"/>
               </a:rPr>
-              <a:t>phủ ODD trong phạm vi
-72/72 ô · 74/74 cặp</a:t>
+              <a:t>va chạm thật
+trên CARLA</a:t>
             </a:r>
           </a:p>
         </p:txBody>
@@ -11208,7 +11269,7 @@
                 </a:solidFill>
                 <a:latin typeface="Arial"/>
               </a:rPr>
-              <a:t>76%</a:t>
+              <a:t>64%</a:t>
             </a:r>
           </a:p>
           <a:p>
@@ -11318,11 +11379,11 @@
             <a:r>
               <a:rPr sz="3200" b="1" i="0">
                 <a:solidFill>
-                  <a:srgbClr val="00A651"/>
+                  <a:srgbClr val="2F62B8"/>
                 </a:solidFill>
                 <a:latin typeface="Arial"/>
               </a:rPr>
-              <a:t>25</a:t>
+              <a:t>75/75</a:t>
             </a:r>
           </a:p>
           <a:p>
@@ -11344,8 +11405,8 @@
                 </a:solidFill>
                 <a:latin typeface="Arial"/>
               </a:rPr>
-              <a:t>va chạm thật
-trên CARLA</a:t>
+              <a:t>ô ODD đã chạy CARLA
+thật, không còn ô trống</a:t>
             </a:r>
           </a:p>
         </p:txBody>

</xml_diff>

<commit_message>
fix: polish near-miss demo and production frontend
</commit_message>
<xml_diff>
--- a/presentation/pitch_deck.pptx
+++ b/presentation/pitch_deck.pptx
@@ -1245,6 +1245,32 @@
           <a:p>
             <a:r>
               <a:t>L2 một trăm phần trăm. L3 chín mươi tám. L4 sáu mươi bốn.</a:t>
+            </a:r>
+          </a:p>
+          <a:p/>
+          <a:p>
+            <a:r>
+              <a:t>Ba con số dưới tách riêng bằng chứng vật lý và coverage: sáu mươi mốt lượt va</a:t>
+            </a:r>
+          </a:p>
+          <a:p>
+            <a:r>
+              <a:t>chạm thật, mười chín lượt không chạm nhưng khe hở dưới một mét, và đủ bảy mươi</a:t>
+            </a:r>
+          </a:p>
+          <a:p>
+            <a:r>
+              <a:t>hai ô nằm trong phạm vi converter đã có lượt CARLA. Ngoài phạm vi chính còn ba</a:t>
+            </a:r>
+          </a:p>
+          <a:p>
+            <a:r>
+              <a:t>ô lịch sử đã chạy; em không dùng cách viết 75/75 vì mẫu số chính thức của phạm</a:t>
+            </a:r>
+          </a:p>
+          <a:p>
+            <a:r>
+              <a:t>vi hỗ trợ là 72.</a:t>
             </a:r>
           </a:p>
           <a:p/>
@@ -11269,7 +11295,7 @@
                 </a:solidFill>
                 <a:latin typeface="Arial"/>
               </a:rPr>
-              <a:t>64%</a:t>
+              <a:t>19</a:t>
             </a:r>
           </a:p>
           <a:p>
@@ -11291,8 +11317,8 @@
                 </a:solidFill>
                 <a:latin typeface="Arial"/>
               </a:rPr>
-              <a:t>kịch bản tái hiện
-được nguy hiểm</a:t>
+              <a:t>ca suýt va chạm
+dưới 1 mét</a:t>
             </a:r>
           </a:p>
         </p:txBody>
@@ -11383,7 +11409,7 @@
                 </a:solidFill>
                 <a:latin typeface="Arial"/>
               </a:rPr>
-              <a:t>75/75</a:t>
+              <a:t>72/72</a:t>
             </a:r>
           </a:p>
           <a:p>
@@ -11405,8 +11431,8 @@
                 </a:solidFill>
                 <a:latin typeface="Arial"/>
               </a:rPr>
-              <a:t>ô ODD đã chạy CARLA
-thật, không còn ô trống</a:t>
+              <a:t>ô ODD trong phạm vi
+đã chạy CARLA thật</a:t>
             </a:r>
           </a:p>
         </p:txBody>

</xml_diff>

<commit_message>
docs: align Demo Day evidence with production snapshot
</commit_message>
<xml_diff>
--- a/presentation/pitch_deck.pptx
+++ b/presentation/pitch_deck.pptx
@@ -1244,13 +1244,13 @@
           <a:p/>
           <a:p>
             <a:r>
-              <a:t>L2 một trăm phần trăm. L3 chín mươi tám. L4 sáu mươi bốn.</a:t>
+              <a:t>L2 một trăm phần trăm. L3 một trăm phần trăm. L4 sáu mươi bốn.</a:t>
             </a:r>
           </a:p>
           <a:p/>
           <a:p>
             <a:r>
-              <a:t>Ba con số dưới tách riêng bằng chứng vật lý và coverage: sáu mươi mốt lượt va</a:t>
+              <a:t>Ba con số dưới tách riêng bằng chứng vật lý và coverage: sáu mươi ba lượt va</a:t>
             </a:r>
           </a:p>
           <a:p>
@@ -10837,7 +10837,7 @@
         <p:spPr>
           <a:xfrm>
             <a:off x="4434840" y="2606040"/>
-            <a:ext cx="4539680" cy="274320"/>
+            <a:ext cx="4617720" cy="274320"/>
           </a:xfrm>
           <a:prstGeom prst="round2SameRect">
             <a:avLst/>
@@ -10912,7 +10912,7 @@
                 </a:solidFill>
                 <a:latin typeface="Arial"/>
               </a:rPr>
-              <a:t>98,3%  ·  116/118</a:t>
+              <a:t>100,0%  ·  119/119</a:t>
             </a:r>
           </a:p>
         </p:txBody>
@@ -11015,7 +11015,7 @@
         <p:spPr>
           <a:xfrm>
             <a:off x="4434840" y="3264408"/>
-            <a:ext cx="2971502" cy="274320"/>
+            <a:ext cx="2974273" cy="274320"/>
           </a:xfrm>
           <a:prstGeom prst="round2SameRect">
             <a:avLst/>
@@ -11090,7 +11090,7 @@
                 </a:solidFill>
                 <a:latin typeface="Arial"/>
               </a:rPr>
-              <a:t>64,3%  ·  74/115</a:t>
+              <a:t>64,4%  ·  76/118</a:t>
             </a:r>
           </a:p>
         </p:txBody>
@@ -11181,7 +11181,7 @@
                 </a:solidFill>
                 <a:latin typeface="Arial"/>
               </a:rPr>
-              <a:t>61</a:t>
+              <a:t>63</a:t>
             </a:r>
           </a:p>
           <a:p>

</xml_diff>